<commit_message>
Block git in the race and fill slide 23 with rehearsal results
Personal git rules (branch, commit, treat other changes as unrelated) moved or
discarded work between tasks in two rehearsal races, so the scorer saw failures
that weren't real. Both lanes now run with Bash(git:*) disallowed; the clean
profile becomes optional.

Slide 23 now carries a rehearsal run as the fallback: vibe 2/3, disciplined
3/3 (free shipping is the difference), $0.90 vs $0.60, 60.0k vs 51.3k peak
context, 5 full suite runs vs 3 focused.

Co-Authored-By: Claude Opus 5.5 (1M context) <noreply@anthropic.com>
</commit_message>
<xml_diff>
--- a/presentation/vibe-vs-verified.pptx
+++ b/presentation/vibe-vs-verified.pptx
@@ -133,14 +133,14 @@
   <p:extLst>
     <p:ext uri="{521415D9-36F7-43E2-AB2F-B90AF26B5E84}">
       <p14:sectionLst xmlns:p14="http://schemas.microsoft.com/office/powerpoint/2010/main">
-        <p14:section name="Open" id="{c7f3685e-0c56-5faf-a489-838b025888e1}">
+        <p14:section name="Open" id="{8d21334a-dc7a-f962-1f8e-a844951e69f8}">
           <p14:sldIdLst>
             <p14:sldId id="256"/>
             <p14:sldId id="257"/>
             <p14:sldId id="258"/>
           </p14:sldIdLst>
         </p14:section>
-        <p14:section name="Theory 1 - Context" id="{a66c730b-b8db-2779-b6f9-275b1d268242}">
+        <p14:section name="Theory 1 - Context" id="{5b461ad3-e78c-8280-4b48-3daee8309e33}">
           <p14:sldIdLst>
             <p14:sldId id="259"/>
             <p14:sldId id="260"/>
@@ -148,12 +148,12 @@
             <p14:sldId id="262"/>
           </p14:sldIdLst>
         </p14:section>
-        <p14:section name="Demo 1 - Vibe" id="{e6daab85-f23a-29cf-9a66-31b7ad79415e}">
+        <p14:section name="Demo 1 - Vibe" id="{8a1147e1-2619-47b4-a0fb-a85eba30591d}">
           <p14:sldIdLst>
             <p14:sldId id="263"/>
           </p14:sldIdLst>
         </p14:section>
-        <p14:section name="Theory 2 - Planning" id="{cf2fd7a0-7217-55c7-faad-31654ffe7aed}">
+        <p14:section name="Theory 2 - Planning" id="{c5952fae-5029-514d-b3f1-74f3e7851f31}">
           <p14:sldIdLst>
             <p14:sldId id="264"/>
             <p14:sldId id="265"/>
@@ -164,12 +164,12 @@
             <p14:sldId id="270"/>
           </p14:sldIdLst>
         </p14:section>
-        <p14:section name="Demo 2 - Disciplined" id="{abad094d-ed67-59fb-e275-a545b5fa5cb9}">
+        <p14:section name="Demo 2 - Disciplined" id="{87060cc4-7ad5-72f1-bc8a-47f876e5a78a}">
           <p14:sldIdLst>
             <p14:sldId id="271"/>
           </p14:sldIdLst>
         </p14:section>
-        <p14:section name="Theory 3 - Context" id="{c6623b92-6c22-f81c-20c8-9eef5ae539f3}">
+        <p14:section name="Theory 3 - Context" id="{10a5dd2d-0eca-48fe-3350-1aa5efb62e17}">
           <p14:sldIdLst>
             <p14:sldId id="272"/>
             <p14:sldId id="273"/>
@@ -178,19 +178,19 @@
             <p14:sldId id="276"/>
           </p14:sldIdLst>
         </p14:section>
-        <p14:section name="Demo 3 - Cursor CLI" id="{508c662f-c384-020c-a470-bdcf7db4ed21}">
+        <p14:section name="Demo 3 - Cursor CLI" id="{01565d76-672e-a1ca-982d-5910d35f4631}">
           <p14:sldIdLst>
             <p14:sldId id="277"/>
           </p14:sldIdLst>
         </p14:section>
-        <p14:section name="Close" id="{22fcbfcd-687a-99f1-372a-e21110279868}">
+        <p14:section name="Close" id="{c1fc7d45-3690-638e-e8b6-23fe0df3148d}">
           <p14:sldIdLst>
             <p14:sldId id="278"/>
             <p14:sldId id="279"/>
             <p14:sldId id="280"/>
           </p14:sldIdLst>
         </p14:section>
-        <p14:section name="Backup" id="{58ab62d4-7f5e-e7ab-e919-0929bdf60eb1}">
+        <p14:section name="Backup" id="{3655b423-e01a-fdb2-e5ea-5c6632d58ead}">
           <p14:sldIdLst>
             <p14:sldId id="281"/>
             <p14:sldId id="282"/>
@@ -1216,7 +1216,7 @@
           <a:p>
             <a:r>
               <a:rPr lang="en-US" dirty="0"/>
-              <a:t>ADAM drives the Claude Code CLI (clean profile) in parcel-pilot-stage/demo2-disciplined, EUGENE narrates and keeps the same tally as Demo 1. Prompts: demo-kit/prompts.md (disciplined-1, disciplined-3, save-plan, build-from-plan). Step 2: 'same ticket Demo 1 got wrong - this time we say the two things we knew.' At step 3 ask the room 'what would you change in this plan?'. At step 4, read /context before and after /clear as numbers - a fresh session still holds the system prompt and CLAUDE.md, so the floor isn't zero. Step 5: run verify.mjs ... 1 3 - Task 3 passes here and failed in Demo 1.</a:t>
+              <a:t>ADAM drives the Claude Code CLI in parcel-pilot-stage/demo2-disciplined, EUGENE narrates and keeps the same tally as Demo 1. Prompts: demo-kit/prompts.md (disciplined-1, disciplined-3, save-plan, build-from-plan). Step 2: 'same ticket Demo 1 got wrong - this time we say the two things we knew.' At step 3 ask the room 'what would you change in this plan?'. At step 4, read /context before and after /clear as numbers - a fresh session still holds the system prompt and CLAUDE.md, so the floor isn't zero. Step 5: run verify.mjs ... 1 3 - Task 3 passes here and failed in Demo 1.</a:t>
             </a:r>
             <a:endParaRPr lang="en-US" dirty="0"/>
           </a:p>
@@ -1920,7 +1920,7 @@
           <a:p>
             <a:r>
               <a:rPr lang="en-US" dirty="0"/>
-              <a:t>BOTH. Eugene switches to the race terminal - the scoreboard prints when both lanes finish (results also saved in demo-kit/results/). Adam reads the rows top-down: correctness first, then tokens and context, then files. Fill the '_' cells in this slide from your rehearsal run so there's a fallback if the live race hasn't finished. If the vibe lane got everything right: point at tokens, peak context and files read - it paid more to get there.</a:t>
+              <a:t>BOTH. Eugene switches to the race terminal - the scoreboard prints when both lanes finish (results also saved in demo-kit/results/). Adam reads the rows top-down: correctness first, then tokens and context, then files. The numbers on this slide are from a rehearsal run - the fallback if the live race hasn't finished; say so if you use them. The failed vibe task is free shipping: 'over £100' became '&gt; 10000' and express went free too. Then cost and context: a third more spend for a worse result. Files read is a wash on this repo - good docs keep both lanes on the right files - so don't oversell it.</a:t>
             </a:r>
             <a:endParaRPr lang="en-US" dirty="0"/>
           </a:p>
@@ -2800,7 +2800,7 @@
           <a:p>
             <a:r>
               <a:rPr lang="en-US" dirty="0"/>
-              <a:t>EUGENE drives, ADAM narrates and tallies. Eugene: fresh Claude Code session (clean profile) in parcel-pilot-stage/demo1-vibe, status line visible. Paste prompt 1 - expect the tax fix to be right; say 'good docs and a failing test did our job for us'. Then prompt 2 in the SAME chat; ask the room if anyone sees a problem with the ticket. When it finishes, run the hidden check: node demo-kit/verify.mjs ../../parcel-pilot-stage/demo1-vibe 1 3. In rehearsal Task 3 failed every time: '&gt; 10000' means exactly £100 still pays, and express went free too. Open shipping-price.ts and show the one if. Then /context. Adam: 'It did exactly what we asked. The bug is in the prompt.'</a:t>
+              <a:t>EUGENE drives, ADAM narrates and tallies. Eugene: fresh Claude Code session in parcel-pilot-stage/demo1-vibe, status line visible. Paste prompt 1 - expect the tax fix to be right; say 'good docs and a failing test did our job for us'. Then prompt 2 in the SAME chat; ask the room if anyone sees a problem with the ticket. When it finishes, run the hidden check: node demo-kit/verify.mjs ../../parcel-pilot-stage/demo1-vibe 1 3. In rehearsal Task 3 failed every time: '&gt; 10000' means exactly £100 still pays, and express went free too. Open shipping-price.ts and show the one if. Then /context. Adam: 'It did exactly what we asked. The bug is in the prompt.'</a:t>
             </a:r>
             <a:endParaRPr lang="en-US" dirty="0"/>
           </a:p>
@@ -17888,7 +17888,7 @@
                             <a:schemeClr val="tx1"/>
                           </a:solidFill>
                         </a:rPr>
-                        <a:t>_ / 3</a:t>
+                        <a:t>2 / 3</a:t>
                       </a:r>
                       <a:endParaRPr lang="en-US" sz="1500" dirty="0"/>
                     </a:p>
@@ -17946,7 +17946,7 @@
                             <a:schemeClr val="tx1"/>
                           </a:solidFill>
                         </a:rPr>
-                        <a:t>_ / 3</a:t>
+                        <a:t>3 / 3</a:t>
                       </a:r>
                       <a:endParaRPr lang="en-US" sz="1500" dirty="0"/>
                     </a:p>
@@ -18064,7 +18064,7 @@
                             <a:schemeClr val="tx1"/>
                           </a:solidFill>
                         </a:rPr>
-                        <a:t>_</a:t>
+                        <a:t>907k</a:t>
                       </a:r>
                       <a:endParaRPr lang="en-US" sz="1500" dirty="0"/>
                     </a:p>
@@ -18122,7 +18122,7 @@
                             <a:schemeClr val="tx1"/>
                           </a:solidFill>
                         </a:rPr>
-                        <a:t>_</a:t>
+                        <a:t>729k</a:t>
                       </a:r>
                       <a:endParaRPr lang="en-US" sz="1500" dirty="0"/>
                     </a:p>
@@ -18240,7 +18240,7 @@
                             <a:schemeClr val="tx1"/>
                           </a:solidFill>
                         </a:rPr>
-                        <a:t>_</a:t>
+                        <a:t>60.0k</a:t>
                       </a:r>
                       <a:endParaRPr lang="en-US" sz="1500" dirty="0"/>
                     </a:p>
@@ -18298,7 +18298,7 @@
                             <a:schemeClr val="tx1"/>
                           </a:solidFill>
                         </a:rPr>
-                        <a:t>_</a:t>
+                        <a:t>51.3k</a:t>
                       </a:r>
                       <a:endParaRPr lang="en-US" sz="1500" dirty="0"/>
                     </a:p>
@@ -18416,7 +18416,7 @@
                             <a:schemeClr val="tx1"/>
                           </a:solidFill>
                         </a:rPr>
-                        <a:t>_</a:t>
+                        <a:t>$0.90</a:t>
                       </a:r>
                       <a:endParaRPr lang="en-US" sz="1500" dirty="0"/>
                     </a:p>
@@ -18474,7 +18474,183 @@
                             <a:schemeClr val="tx1"/>
                           </a:solidFill>
                         </a:rPr>
-                        <a:t>_</a:t>
+                        <a:t>$0.60</a:t>
+                      </a:r>
+                      <a:endParaRPr lang="en-US" sz="1500" dirty="0"/>
+                    </a:p>
+                  </a:txBody>
+                  <a:tcPr marL="128016" marR="128016" marT="36576" marB="36576" anchor="ctr">
+                    <a:lnL w="12700" cap="flat" cmpd="sng" algn="ctr">
+                      <a:solidFill>
+                        <a:srgbClr val="EAF0F4"/>
+                      </a:solidFill>
+                      <a:prstDash val="solid"/>
+                      <a:round/>
+                      <a:headEnd type="none" w="med" len="med"/>
+                      <a:tailEnd type="none" w="med" len="med"/>
+                    </a:lnL>
+                    <a:lnR w="12700" cap="flat" cmpd="sng" algn="ctr">
+                      <a:solidFill>
+                        <a:srgbClr val="EAF0F4"/>
+                      </a:solidFill>
+                      <a:prstDash val="solid"/>
+                      <a:round/>
+                      <a:headEnd type="none" w="med" len="med"/>
+                      <a:tailEnd type="none" w="med" len="med"/>
+                    </a:lnR>
+                    <a:lnT w="12700" cap="flat" cmpd="sng" algn="ctr">
+                      <a:solidFill>
+                        <a:srgbClr val="EAF0F4"/>
+                      </a:solidFill>
+                      <a:prstDash val="solid"/>
+                      <a:round/>
+                      <a:headEnd type="none" w="med" len="med"/>
+                      <a:tailEnd type="none" w="med" len="med"/>
+                    </a:lnT>
+                    <a:lnB w="12700" cap="flat" cmpd="sng" algn="ctr">
+                      <a:solidFill>
+                        <a:srgbClr val="EAF0F4"/>
+                      </a:solidFill>
+                      <a:prstDash val="solid"/>
+                      <a:round/>
+                      <a:headEnd type="none" w="med" len="med"/>
+                      <a:tailEnd type="none" w="med" len="med"/>
+                    </a:lnB>
+                  </a:tcPr>
+                </a:tc>
+              </a:tr>
+              <a:tr h="512064">
+                <a:tc>
+                  <a:txBody>
+                    <a:bodyPr/>
+                    <a:lstStyle/>
+                    <a:p>
+                      <a:pPr indent="0" marL="0">
+                        <a:buNone/>
+                      </a:pPr>
+                      <a:r>
+                        <a:rPr lang="en-US" sz="1500" b="1" dirty="0">
+                          <a:solidFill>
+                            <a:schemeClr val="tx1"/>
+                          </a:solidFill>
+                        </a:rPr>
+                        <a:t>Full / focused test runs</a:t>
+                      </a:r>
+                      <a:endParaRPr lang="en-US" sz="1500" dirty="0"/>
+                    </a:p>
+                  </a:txBody>
+                  <a:tcPr marL="128016" marR="128016" marT="36576" marB="36576" anchor="ctr">
+                    <a:lnL w="12700" cap="flat" cmpd="sng" algn="ctr">
+                      <a:solidFill>
+                        <a:srgbClr val="EAF0F4"/>
+                      </a:solidFill>
+                      <a:prstDash val="solid"/>
+                      <a:round/>
+                      <a:headEnd type="none" w="med" len="med"/>
+                      <a:tailEnd type="none" w="med" len="med"/>
+                    </a:lnL>
+                    <a:lnR w="12700" cap="flat" cmpd="sng" algn="ctr">
+                      <a:solidFill>
+                        <a:srgbClr val="EAF0F4"/>
+                      </a:solidFill>
+                      <a:prstDash val="solid"/>
+                      <a:round/>
+                      <a:headEnd type="none" w="med" len="med"/>
+                      <a:tailEnd type="none" w="med" len="med"/>
+                    </a:lnR>
+                    <a:lnT w="12700" cap="flat" cmpd="sng" algn="ctr">
+                      <a:solidFill>
+                        <a:srgbClr val="EAF0F4"/>
+                      </a:solidFill>
+                      <a:prstDash val="solid"/>
+                      <a:round/>
+                      <a:headEnd type="none" w="med" len="med"/>
+                      <a:tailEnd type="none" w="med" len="med"/>
+                    </a:lnT>
+                    <a:lnB w="12700" cap="flat" cmpd="sng" algn="ctr">
+                      <a:solidFill>
+                        <a:srgbClr val="EAF0F4"/>
+                      </a:solidFill>
+                      <a:prstDash val="solid"/>
+                      <a:round/>
+                      <a:headEnd type="none" w="med" len="med"/>
+                      <a:tailEnd type="none" w="med" len="med"/>
+                    </a:lnB>
+                  </a:tcPr>
+                </a:tc>
+                <a:tc>
+                  <a:txBody>
+                    <a:bodyPr/>
+                    <a:lstStyle/>
+                    <a:p>
+                      <a:pPr algn="ctr" indent="0" marL="0">
+                        <a:buNone/>
+                      </a:pPr>
+                      <a:r>
+                        <a:rPr lang="en-US" sz="1500" dirty="0">
+                          <a:solidFill>
+                            <a:schemeClr val="tx1"/>
+                          </a:solidFill>
+                        </a:rPr>
+                        <a:t>5 / 0</a:t>
+                      </a:r>
+                      <a:endParaRPr lang="en-US" sz="1500" dirty="0"/>
+                    </a:p>
+                  </a:txBody>
+                  <a:tcPr marL="128016" marR="128016" marT="36576" marB="36576" anchor="ctr">
+                    <a:lnL w="12700" cap="flat" cmpd="sng" algn="ctr">
+                      <a:solidFill>
+                        <a:srgbClr val="EAF0F4"/>
+                      </a:solidFill>
+                      <a:prstDash val="solid"/>
+                      <a:round/>
+                      <a:headEnd type="none" w="med" len="med"/>
+                      <a:tailEnd type="none" w="med" len="med"/>
+                    </a:lnL>
+                    <a:lnR w="12700" cap="flat" cmpd="sng" algn="ctr">
+                      <a:solidFill>
+                        <a:srgbClr val="EAF0F4"/>
+                      </a:solidFill>
+                      <a:prstDash val="solid"/>
+                      <a:round/>
+                      <a:headEnd type="none" w="med" len="med"/>
+                      <a:tailEnd type="none" w="med" len="med"/>
+                    </a:lnR>
+                    <a:lnT w="12700" cap="flat" cmpd="sng" algn="ctr">
+                      <a:solidFill>
+                        <a:srgbClr val="EAF0F4"/>
+                      </a:solidFill>
+                      <a:prstDash val="solid"/>
+                      <a:round/>
+                      <a:headEnd type="none" w="med" len="med"/>
+                      <a:tailEnd type="none" w="med" len="med"/>
+                    </a:lnT>
+                    <a:lnB w="12700" cap="flat" cmpd="sng" algn="ctr">
+                      <a:solidFill>
+                        <a:srgbClr val="EAF0F4"/>
+                      </a:solidFill>
+                      <a:prstDash val="solid"/>
+                      <a:round/>
+                      <a:headEnd type="none" w="med" len="med"/>
+                      <a:tailEnd type="none" w="med" len="med"/>
+                    </a:lnB>
+                  </a:tcPr>
+                </a:tc>
+                <a:tc>
+                  <a:txBody>
+                    <a:bodyPr/>
+                    <a:lstStyle/>
+                    <a:p>
+                      <a:pPr algn="ctr" indent="0" marL="0">
+                        <a:buNone/>
+                      </a:pPr>
+                      <a:r>
+                        <a:rPr lang="en-US" sz="1500" dirty="0">
+                          <a:solidFill>
+                            <a:schemeClr val="tx1"/>
+                          </a:solidFill>
+                        </a:rPr>
+                        <a:t>0 / 3</a:t>
                       </a:r>
                       <a:endParaRPr lang="en-US" sz="1500" dirty="0"/>
                     </a:p>
@@ -18592,7 +18768,7 @@
                             <a:schemeClr val="tx1"/>
                           </a:solidFill>
                         </a:rPr>
-                        <a:t>_</a:t>
+                        <a:t>7 · 100%</a:t>
                       </a:r>
                       <a:endParaRPr lang="en-US" sz="1500" dirty="0"/>
                     </a:p>
@@ -18650,183 +18826,7 @@
                             <a:schemeClr val="tx1"/>
                           </a:solidFill>
                         </a:rPr>
-                        <a:t>_</a:t>
-                      </a:r>
-                      <a:endParaRPr lang="en-US" sz="1500" dirty="0"/>
-                    </a:p>
-                  </a:txBody>
-                  <a:tcPr marL="128016" marR="128016" marT="36576" marB="36576" anchor="ctr">
-                    <a:lnL w="12700" cap="flat" cmpd="sng" algn="ctr">
-                      <a:solidFill>
-                        <a:srgbClr val="EAF0F4"/>
-                      </a:solidFill>
-                      <a:prstDash val="solid"/>
-                      <a:round/>
-                      <a:headEnd type="none" w="med" len="med"/>
-                      <a:tailEnd type="none" w="med" len="med"/>
-                    </a:lnL>
-                    <a:lnR w="12700" cap="flat" cmpd="sng" algn="ctr">
-                      <a:solidFill>
-                        <a:srgbClr val="EAF0F4"/>
-                      </a:solidFill>
-                      <a:prstDash val="solid"/>
-                      <a:round/>
-                      <a:headEnd type="none" w="med" len="med"/>
-                      <a:tailEnd type="none" w="med" len="med"/>
-                    </a:lnR>
-                    <a:lnT w="12700" cap="flat" cmpd="sng" algn="ctr">
-                      <a:solidFill>
-                        <a:srgbClr val="EAF0F4"/>
-                      </a:solidFill>
-                      <a:prstDash val="solid"/>
-                      <a:round/>
-                      <a:headEnd type="none" w="med" len="med"/>
-                      <a:tailEnd type="none" w="med" len="med"/>
-                    </a:lnT>
-                    <a:lnB w="12700" cap="flat" cmpd="sng" algn="ctr">
-                      <a:solidFill>
-                        <a:srgbClr val="EAF0F4"/>
-                      </a:solidFill>
-                      <a:prstDash val="solid"/>
-                      <a:round/>
-                      <a:headEnd type="none" w="med" len="med"/>
-                      <a:tailEnd type="none" w="med" len="med"/>
-                    </a:lnB>
-                  </a:tcPr>
-                </a:tc>
-              </a:tr>
-              <a:tr h="512064">
-                <a:tc>
-                  <a:txBody>
-                    <a:bodyPr/>
-                    <a:lstStyle/>
-                    <a:p>
-                      <a:pPr indent="0" marL="0">
-                        <a:buNone/>
-                      </a:pPr>
-                      <a:r>
-                        <a:rPr lang="en-US" sz="1500" b="1" dirty="0">
-                          <a:solidFill>
-                            <a:schemeClr val="tx1"/>
-                          </a:solidFill>
-                        </a:rPr>
-                        <a:t>Files changed that didn't need to</a:t>
-                      </a:r>
-                      <a:endParaRPr lang="en-US" sz="1500" dirty="0"/>
-                    </a:p>
-                  </a:txBody>
-                  <a:tcPr marL="128016" marR="128016" marT="36576" marB="36576" anchor="ctr">
-                    <a:lnL w="12700" cap="flat" cmpd="sng" algn="ctr">
-                      <a:solidFill>
-                        <a:srgbClr val="EAF0F4"/>
-                      </a:solidFill>
-                      <a:prstDash val="solid"/>
-                      <a:round/>
-                      <a:headEnd type="none" w="med" len="med"/>
-                      <a:tailEnd type="none" w="med" len="med"/>
-                    </a:lnL>
-                    <a:lnR w="12700" cap="flat" cmpd="sng" algn="ctr">
-                      <a:solidFill>
-                        <a:srgbClr val="EAF0F4"/>
-                      </a:solidFill>
-                      <a:prstDash val="solid"/>
-                      <a:round/>
-                      <a:headEnd type="none" w="med" len="med"/>
-                      <a:tailEnd type="none" w="med" len="med"/>
-                    </a:lnR>
-                    <a:lnT w="12700" cap="flat" cmpd="sng" algn="ctr">
-                      <a:solidFill>
-                        <a:srgbClr val="EAF0F4"/>
-                      </a:solidFill>
-                      <a:prstDash val="solid"/>
-                      <a:round/>
-                      <a:headEnd type="none" w="med" len="med"/>
-                      <a:tailEnd type="none" w="med" len="med"/>
-                    </a:lnT>
-                    <a:lnB w="12700" cap="flat" cmpd="sng" algn="ctr">
-                      <a:solidFill>
-                        <a:srgbClr val="EAF0F4"/>
-                      </a:solidFill>
-                      <a:prstDash val="solid"/>
-                      <a:round/>
-                      <a:headEnd type="none" w="med" len="med"/>
-                      <a:tailEnd type="none" w="med" len="med"/>
-                    </a:lnB>
-                  </a:tcPr>
-                </a:tc>
-                <a:tc>
-                  <a:txBody>
-                    <a:bodyPr/>
-                    <a:lstStyle/>
-                    <a:p>
-                      <a:pPr algn="ctr" indent="0" marL="0">
-                        <a:buNone/>
-                      </a:pPr>
-                      <a:r>
-                        <a:rPr lang="en-US" sz="1500" dirty="0">
-                          <a:solidFill>
-                            <a:schemeClr val="tx1"/>
-                          </a:solidFill>
-                        </a:rPr>
-                        <a:t>_</a:t>
-                      </a:r>
-                      <a:endParaRPr lang="en-US" sz="1500" dirty="0"/>
-                    </a:p>
-                  </a:txBody>
-                  <a:tcPr marL="128016" marR="128016" marT="36576" marB="36576" anchor="ctr">
-                    <a:lnL w="12700" cap="flat" cmpd="sng" algn="ctr">
-                      <a:solidFill>
-                        <a:srgbClr val="EAF0F4"/>
-                      </a:solidFill>
-                      <a:prstDash val="solid"/>
-                      <a:round/>
-                      <a:headEnd type="none" w="med" len="med"/>
-                      <a:tailEnd type="none" w="med" len="med"/>
-                    </a:lnL>
-                    <a:lnR w="12700" cap="flat" cmpd="sng" algn="ctr">
-                      <a:solidFill>
-                        <a:srgbClr val="EAF0F4"/>
-                      </a:solidFill>
-                      <a:prstDash val="solid"/>
-                      <a:round/>
-                      <a:headEnd type="none" w="med" len="med"/>
-                      <a:tailEnd type="none" w="med" len="med"/>
-                    </a:lnR>
-                    <a:lnT w="12700" cap="flat" cmpd="sng" algn="ctr">
-                      <a:solidFill>
-                        <a:srgbClr val="EAF0F4"/>
-                      </a:solidFill>
-                      <a:prstDash val="solid"/>
-                      <a:round/>
-                      <a:headEnd type="none" w="med" len="med"/>
-                      <a:tailEnd type="none" w="med" len="med"/>
-                    </a:lnT>
-                    <a:lnB w="12700" cap="flat" cmpd="sng" algn="ctr">
-                      <a:solidFill>
-                        <a:srgbClr val="EAF0F4"/>
-                      </a:solidFill>
-                      <a:prstDash val="solid"/>
-                      <a:round/>
-                      <a:headEnd type="none" w="med" len="med"/>
-                      <a:tailEnd type="none" w="med" len="med"/>
-                    </a:lnB>
-                  </a:tcPr>
-                </a:tc>
-                <a:tc>
-                  <a:txBody>
-                    <a:bodyPr/>
-                    <a:lstStyle/>
-                    <a:p>
-                      <a:pPr algn="ctr" indent="0" marL="0">
-                        <a:buNone/>
-                      </a:pPr>
-                      <a:r>
-                        <a:rPr lang="en-US" sz="1500" dirty="0">
-                          <a:solidFill>
-                            <a:schemeClr val="tx1"/>
-                          </a:solidFill>
-                        </a:rPr>
-                        <a:t>_</a:t>
+                        <a:t>9 · 89%</a:t>
                       </a:r>
                       <a:endParaRPr lang="en-US" sz="1500" dirty="0"/>
                     </a:p>
@@ -18944,7 +18944,7 @@
                             <a:schemeClr val="tx1"/>
                           </a:solidFill>
                         </a:rPr>
-                        <a:t>_</a:t>
+                        <a:t>2.2</a:t>
                       </a:r>
                       <a:endParaRPr lang="en-US" sz="1500" dirty="0"/>
                     </a:p>
@@ -19002,7 +19002,7 @@
                             <a:schemeClr val="tx1"/>
                           </a:solidFill>
                         </a:rPr>
-                        <a:t>_</a:t>
+                        <a:t>1.7</a:t>
                       </a:r>
                       <a:endParaRPr lang="en-US" sz="1500" dirty="0"/>
                     </a:p>

</xml_diff>

<commit_message>
Run every demo in Claude Code; keep Cursor as reference
Demo 3 moves from the Cursor CLI to Claude Code: fresh session with /clear,
plan mode via Shift+Tab, /compact instead of /summarize, and the layer-2
lesson saved as a path-scoped .claude/rules/notifications.md (paths:
frontmatter, loaded only when Claude reads or edits a matching file).

Cursor stays where it helps Cursor users: the tool-map backup slide, the
cheat-sheet columns, the layer-2 row and the Q&A answer. Cursor-only prep
(status line config, agent sign-in) is gone from the run of show.

- stage.mjs: demo3-cursor becomes demo3-notifications.
- demo-kit: claude-rule-example/notifications.md replaces the .mdc.
- Rehearsed headless: reads the 3 relevant files, avoids the
  maxRetries trap, Task 4 passes.

Co-Authored-By: Claude Opus 5.5 (1M context) <noreply@anthropic.com>
</commit_message>
<xml_diff>
--- a/presentation/vibe-vs-verified.pptx
+++ b/presentation/vibe-vs-verified.pptx
@@ -133,14 +133,14 @@
   <p:extLst>
     <p:ext uri="{521415D9-36F7-43E2-AB2F-B90AF26B5E84}">
       <p14:sectionLst xmlns:p14="http://schemas.microsoft.com/office/powerpoint/2010/main">
-        <p14:section name="Open" id="{8d21334a-dc7a-f962-1f8e-a844951e69f8}">
+        <p14:section name="Open" id="{0c86d74f-007e-1810-adbc-ea543e438bde}">
           <p14:sldIdLst>
             <p14:sldId id="256"/>
             <p14:sldId id="257"/>
             <p14:sldId id="258"/>
           </p14:sldIdLst>
         </p14:section>
-        <p14:section name="Theory 1 - Context" id="{5b461ad3-e78c-8280-4b48-3daee8309e33}">
+        <p14:section name="Theory 1 - Context" id="{4bd7b357-e757-452b-b498-26d0fd66136f}">
           <p14:sldIdLst>
             <p14:sldId id="259"/>
             <p14:sldId id="260"/>
@@ -148,12 +148,12 @@
             <p14:sldId id="262"/>
           </p14:sldIdLst>
         </p14:section>
-        <p14:section name="Demo 1 - Vibe" id="{8a1147e1-2619-47b4-a0fb-a85eba30591d}">
+        <p14:section name="Demo 1 - Vibe" id="{7b5e6853-eebf-bb63-b00d-d782a7e818dd}">
           <p14:sldIdLst>
             <p14:sldId id="263"/>
           </p14:sldIdLst>
         </p14:section>
-        <p14:section name="Theory 2 - Planning" id="{c5952fae-5029-514d-b3f1-74f3e7851f31}">
+        <p14:section name="Theory 2 - Planning" id="{ab9f51fa-e18e-c10d-e865-cb9bd5c218d5}">
           <p14:sldIdLst>
             <p14:sldId id="264"/>
             <p14:sldId id="265"/>
@@ -164,12 +164,12 @@
             <p14:sldId id="270"/>
           </p14:sldIdLst>
         </p14:section>
-        <p14:section name="Demo 2 - Disciplined" id="{87060cc4-7ad5-72f1-bc8a-47f876e5a78a}">
+        <p14:section name="Demo 2 - Disciplined" id="{a63d7c43-6bf3-5f07-1378-b5e63b6b6a15}">
           <p14:sldIdLst>
             <p14:sldId id="271"/>
           </p14:sldIdLst>
         </p14:section>
-        <p14:section name="Theory 3 - Context" id="{10a5dd2d-0eca-48fe-3350-1aa5efb62e17}">
+        <p14:section name="Theory 3 - Context" id="{8773123d-37db-fe5a-2d6f-865f35254f87}">
           <p14:sldIdLst>
             <p14:sldId id="272"/>
             <p14:sldId id="273"/>
@@ -178,19 +178,19 @@
             <p14:sldId id="276"/>
           </p14:sldIdLst>
         </p14:section>
-        <p14:section name="Demo 3 - Cursor CLI" id="{01565d76-672e-a1ca-982d-5910d35f4631}">
+        <p14:section name="Demo 3 - Fresh context" id="{ae5843b7-c474-07a9-59c2-559d2150c4e5}">
           <p14:sldIdLst>
             <p14:sldId id="277"/>
           </p14:sldIdLst>
         </p14:section>
-        <p14:section name="Close" id="{c1fc7d45-3690-638e-e8b6-23fe0df3148d}">
+        <p14:section name="Close" id="{fc53ddf9-1d88-7cb5-509f-45d21a63f8f9}">
           <p14:sldIdLst>
             <p14:sldId id="278"/>
             <p14:sldId id="279"/>
             <p14:sldId id="280"/>
           </p14:sldIdLst>
         </p14:section>
-        <p14:section name="Backup" id="{3655b423-e01a-fdb2-e5ea-5c6632d58ead}">
+        <p14:section name="Backup" id="{cf46c551-a743-51a0-74d5-10434a08dc4f}">
           <p14:sldIdLst>
             <p14:sldId id="281"/>
             <p14:sldId id="282"/>
@@ -600,7 +600,7 @@
           <a:p>
             <a:r>
               <a:rPr lang="en-US" dirty="0"/>
-              <a:t>ADAM. Welcome. 60 minutes, no laptops needed - we drive, you watch and heckle. We alternate theory and live demos four times so nobody sits through 30 minutes of slides. Promise: everything we show is in the terminal - the Claude Code CLI and the Cursor CLI - and works the same in both, and there is a one-page cheat sheet at the end.</a:t>
+              <a:t>ADAM. Welcome. 60 minutes, no laptops needed - we drive, you watch and heckle. We alternate theory and live demos four times so nobody sits through 30 minutes of slides. Promise: every demo is live in the Claude Code CLI, and every habit works the same in Cursor - the Cursor equivalents are on the cheat sheet you get at the end.</a:t>
             </a:r>
             <a:endParaRPr lang="en-US" dirty="0"/>
           </a:p>
@@ -1744,7 +1744,7 @@
           <a:p>
             <a:r>
               <a:rPr lang="en-US" dirty="0"/>
-              <a:t>ADAM. The instinct after a bad session is 'add it to CLAUDE.md'. Do that for a year and every prompt carries thousands of tokens of folklore. Use the layers. Eugene's going to show the whole thing in the Cursor CLI: a new goal, a fresh context, and a lesson saved as a scoped rule.</a:t>
+              <a:t>ADAM. The instinct after a bad session is 'add it to CLAUDE.md'. Do that for a year and every prompt carries thousands of tokens of folklore. Use the layers. Eugene's going to show the whole thing: a new goal, a fresh context, and a lesson saved as a scoped rule.</a:t>
             </a:r>
             <a:endParaRPr lang="en-US" dirty="0"/>
           </a:p>
@@ -1832,7 +1832,7 @@
           <a:p>
             <a:r>
               <a:rPr lang="en-US" dirty="0"/>
-              <a:t>EUGENE drives the Cursor CLI (`agent`) in parcel-pilot-stage/demo3-cursor, ADAM narrates. Step 1: cat AGENTS.md so the room sees layer 0 is tiny. Step 2: point out the agent reads ADR 003 because the prompt pointed at it - progressive disclosure on demand, not preloaded. The decoys: delivery-queue.ts (when to retry) and notification-log.ts (audit). The trap: the constant is named maxRetries but holds the attempt count - changing it to 2 gives ONE retry. Step 5: create .cursor/rules/notifications.mdc (copy from demo-kit/cursor-rule-example if short on time) - it loads only when the agent touches src/notifications/**. Then: 'Adam, how's the race?'</a:t>
+              <a:t>EUGENE drives the Claude Code CLI in parcel-pilot-stage/demo3-notifications, ADAM narrates. Step 1: cat CLAUDE.md so the room sees layer 0 is short and says nothing about notifications. Step 2: point out the agent reads ADR 003 because the prompt pointed at it - progressive disclosure on demand, not preloaded. The decoys: delivery-queue.ts (when to retry) and notification-log.ts (audit). The trap: the constant is named maxRetries but holds the attempt count - changing it to 2 gives ONE retry. Step 5: create .claude/rules/notifications.md (copy from demo-kit/claude-rule-example if short on time). The paths: frontmatter means Claude loads it only when it reads or edits a matching file. Cursor users: same idea as .cursor/rules/*.mdc with globs. Then: 'Adam, how's the race?'</a:t>
             </a:r>
             <a:endParaRPr lang="en-US" dirty="0"/>
           </a:p>
@@ -2184,7 +2184,7 @@
           <a:p>
             <a:r>
               <a:rPr lang="en-US" dirty="0"/>
-              <a:t>EUGENE. This table is on the cheat sheet, so don't photograph it. Point out: both tools have plan mode, both have mentions, both have compaction and a reset. Adam uses the Claude Code CLI for the next demo; I'll do the last one in the Cursor CLI (agent). Over to Adam.</a:t>
+              <a:t>EUGENE. This table is on the cheat sheet, so don't photograph it. Point out: both tools have plan mode, both have mentions, both have compaction and a reset. We demo in Claude Code; if you use Cursor, every move we made has a column here.</a:t>
             </a:r>
             <a:endParaRPr lang="en-US" dirty="0"/>
           </a:p>
@@ -4017,7 +4017,7 @@
                   <a:schemeClr val="bg2"/>
                 </a:solidFill>
               </a:rPr>
-              <a:t>Token-efficient AI development with the Cursor and Claude Code CLIs</a:t>
+              <a:t>Token-efficient AI development with Claude Code (and Cursor)</a:t>
             </a:r>
             <a:endParaRPr lang="en-US" sz="2400" dirty="0"/>
           </a:p>
@@ -13428,7 +13428,7 @@
                   <a:schemeClr val="bg1"/>
                 </a:solidFill>
               </a:rPr>
-              <a:t>.cursor/rules with globs · nested CLAUDE.md</a:t>
+              <a:t>.claude/rules + paths · nested CLAUDE.md · .cursor/rules</a:t>
             </a:r>
             <a:endParaRPr lang="en-US" sz="1300" dirty="0"/>
           </a:p>
@@ -16692,7 +16692,7 @@
                   <a:schemeClr val="accent5"/>
                 </a:solidFill>
               </a:rPr>
-              <a:t>Cursor CLI (agent) · the subject changes from pricing to notifications</a:t>
+              <a:t>Claude Code CLI · the subject changes from pricing to notifications</a:t>
             </a:r>
             <a:endParaRPr lang="en-US" sz="1600" dirty="0"/>
           </a:p>
@@ -16789,7 +16789,7 @@
                   <a:schemeClr val="bg1"/>
                 </a:solidFill>
               </a:rPr>
-              <a:t>New goal, so /clear. Show AGENTS.md: a few lines, mostly pointers.</a:t>
+              <a:t>New goal, so /clear. Show CLAUDE.md: short, and nothing about notifications.</a:t>
             </a:r>
             <a:endParaRPr lang="en-US" sz="1600" dirty="0"/>
           </a:p>
@@ -16886,7 +16886,7 @@
                   <a:schemeClr val="bg1"/>
                 </a:solidFill>
               </a:rPr>
-              <a:t>Shift+Tab to Plan. @ the retry policy and its test; the prompt points at ADR 003.</a:t>
+              <a:t>Shift+Tab into plan mode. @ the retry policy and its test; the prompt points at ADR 003.</a:t>
             </a:r>
             <a:endParaRPr lang="en-US" sz="1600" dirty="0"/>
           </a:p>
@@ -17080,7 +17080,7 @@
                   <a:schemeClr val="bg1"/>
                 </a:solidFill>
               </a:rPr>
-              <a:t>Build. Narrow test, typecheck, hidden verification. /summarize if it got long.</a:t>
+              <a:t>Build. Narrow test, typecheck, hidden verification. /compact if it got long.</a:t>
             </a:r>
             <a:endParaRPr lang="en-US" sz="1600" dirty="0"/>
           </a:p>
@@ -17177,7 +17177,7 @@
                   <a:schemeClr val="bg1"/>
                 </a:solidFill>
               </a:rPr>
-              <a:t>Save the lesson at layer 2: a scoped rule, not AGENTS.md.</a:t>
+              <a:t>Save the lesson at layer 2: a path-scoped rule, not CLAUDE.md.</a:t>
             </a:r>
             <a:endParaRPr lang="en-US" sz="1600" dirty="0"/>
           </a:p>
@@ -17235,12 +17235,12 @@
               <a:buNone/>
             </a:pPr>
             <a:r>
-              <a:rPr lang="en-US" sz="1200" b="1" spc="100" kern="0" dirty="0">
+              <a:rPr lang="en-US" sz="1200" b="1" dirty="0">
                 <a:solidFill>
                   <a:schemeClr val="accent4"/>
                 </a:solidFill>
               </a:rPr>
-              <a:t>THE SCOPED RULE</a:t>
+              <a:t>.claude/rules/notifications.md</a:t>
             </a:r>
             <a:endParaRPr lang="en-US" sz="1200" dirty="0"/>
           </a:p>
@@ -17296,7 +17296,7 @@
                 <a:ea typeface="Consolas" pitchFamily="34" charset="-122"/>
                 <a:cs typeface="Consolas" pitchFamily="34" charset="-120"/>
               </a:rPr>
-              <a:t>description: Notification retry</a:t>
+              <a:t>paths:</a:t>
             </a:r>
             <a:endParaRPr lang="en-US" sz="1400" dirty="0"/>
           </a:p>
@@ -17313,7 +17313,7 @@
                 <a:ea typeface="Consolas" pitchFamily="34" charset="-122"/>
                 <a:cs typeface="Consolas" pitchFamily="34" charset="-120"/>
               </a:rPr>
-              <a:t>  semantics</a:t>
+              <a:t>  - "src/notifications/**"</a:t>
             </a:r>
             <a:endParaRPr lang="en-US" sz="1400" dirty="0"/>
           </a:p>
@@ -17330,24 +17330,7 @@
                 <a:ea typeface="Consolas" pitchFamily="34" charset="-122"/>
                 <a:cs typeface="Consolas" pitchFamily="34" charset="-120"/>
               </a:rPr>
-              <a:t>globs: src/notifications/**</a:t>
-            </a:r>
-            <a:endParaRPr lang="en-US" sz="1400" dirty="0"/>
-          </a:p>
-          <a:p>
-            <a:pPr indent="0" marL="0">
-              <a:buNone/>
-            </a:pPr>
-            <a:r>
-              <a:rPr lang="en-US" sz="1400" dirty="0">
-                <a:solidFill>
-                  <a:schemeClr val="bg2"/>
-                </a:solidFill>
-                <a:latin typeface="Consolas" pitchFamily="34" charset="0"/>
-                <a:ea typeface="Consolas" pitchFamily="34" charset="-122"/>
-                <a:cs typeface="Consolas" pitchFamily="34" charset="-120"/>
-              </a:rPr>
-              <a:t>alwaysApply: false</a:t>
+              <a:t>  - "tests/notifications/**"</a:t>
             </a:r>
             <a:endParaRPr lang="en-US" sz="1400" dirty="0"/>
           </a:p>
@@ -20276,7 +20259,7 @@
                   <a:schemeClr val="accent3"/>
                 </a:solidFill>
               </a:rPr>
-              <a:t>claude or agent - use whichever you like. The moves are the same.</a:t>
+              <a:t>We demo in claude. If you use Cursor, every move has an equivalent.</a:t>
             </a:r>
             <a:endParaRPr lang="en-US" sz="1500" dirty="0"/>
           </a:p>
@@ -21861,10 +21844,17 @@
                           <a:solidFill>
                             <a:schemeClr val="tx1"/>
                           </a:solidFill>
+                          <a:latin typeface="Consolas" pitchFamily="34" charset="0"/>
+                          <a:ea typeface="Consolas" pitchFamily="34" charset="-122"/>
+                          <a:cs typeface="Consolas" pitchFamily="34" charset="-120"/>
                         </a:rPr>
-                        <a:t>CLAUDE.md (one screen) + docs</a:t>
+                        <a:t>.claude/rules/*.md + paths:</a:t>
                       </a:r>
-                      <a:endParaRPr lang="en-US" sz="1400" dirty="0"/>
+                      <a:endParaRPr lang="en-US" sz="1400" dirty="0">
+                        <a:latin typeface="Consolas" charset="0"/>
+                        <a:ea typeface="Consolas" charset="0"/>
+                        <a:cs typeface="Consolas" charset="0"/>
+                      </a:endParaRPr>
                     </a:p>
                   </a:txBody>
                   <a:tcPr marL="128016" marR="128016" marT="27432" marB="27432" anchor="ctr">
@@ -23975,7 +23965,7 @@
                   <a:schemeClr val="tx1"/>
                 </a:solidFill>
               </a:rPr>
-              <a:t>New goal, fresh context, in the Cursor CLI</a:t>
+              <a:t>New goal, fresh context</a:t>
             </a:r>
             <a:endParaRPr lang="en-US" sz="1800" dirty="0"/>
           </a:p>

</xml_diff>

<commit_message>
Reword the slide 5 heading about misleading files
Co-Authored-By: Claude Opus 5.5 (1M context) <noreply@anthropic.com>
</commit_message>
<xml_diff>
--- a/presentation/vibe-vs-verified.pptx
+++ b/presentation/vibe-vs-verified.pptx
@@ -133,14 +133,14 @@
   <p:extLst>
     <p:ext uri="{521415D9-36F7-43E2-AB2F-B90AF26B5E84}">
       <p14:sectionLst xmlns:p14="http://schemas.microsoft.com/office/powerpoint/2010/main">
-        <p14:section name="Open" id="{0c86d74f-007e-1810-adbc-ea543e438bde}">
+        <p14:section name="Open" id="{32ad6a66-5285-74b9-1956-6aa2e5ea2a40}">
           <p14:sldIdLst>
             <p14:sldId id="256"/>
             <p14:sldId id="257"/>
             <p14:sldId id="258"/>
           </p14:sldIdLst>
         </p14:section>
-        <p14:section name="Theory 1 - Context" id="{4bd7b357-e757-452b-b498-26d0fd66136f}">
+        <p14:section name="Theory 1 - Context" id="{078abeba-5bb7-c4bd-939d-978f9a5a6a86}">
           <p14:sldIdLst>
             <p14:sldId id="259"/>
             <p14:sldId id="260"/>
@@ -148,12 +148,12 @@
             <p14:sldId id="262"/>
           </p14:sldIdLst>
         </p14:section>
-        <p14:section name="Demo 1 - Vibe" id="{7b5e6853-eebf-bb63-b00d-d782a7e818dd}">
+        <p14:section name="Demo 1 - Vibe" id="{37d71a93-590f-78f6-5788-d22bfa953bcc}">
           <p14:sldIdLst>
             <p14:sldId id="263"/>
           </p14:sldIdLst>
         </p14:section>
-        <p14:section name="Theory 2 - Planning" id="{ab9f51fa-e18e-c10d-e865-cb9bd5c218d5}">
+        <p14:section name="Theory 2 - Planning" id="{5e19671c-488b-0c40-71c8-9c585c9acef4}">
           <p14:sldIdLst>
             <p14:sldId id="264"/>
             <p14:sldId id="265"/>
@@ -164,12 +164,12 @@
             <p14:sldId id="270"/>
           </p14:sldIdLst>
         </p14:section>
-        <p14:section name="Demo 2 - Disciplined" id="{a63d7c43-6bf3-5f07-1378-b5e63b6b6a15}">
+        <p14:section name="Demo 2 - Disciplined" id="{09d0afa8-3a22-02ba-4171-b1046c7cecdc}">
           <p14:sldIdLst>
             <p14:sldId id="271"/>
           </p14:sldIdLst>
         </p14:section>
-        <p14:section name="Theory 3 - Context" id="{8773123d-37db-fe5a-2d6f-865f35254f87}">
+        <p14:section name="Theory 3 - Context" id="{a33524fc-9568-8f31-e237-d448f50f2485}">
           <p14:sldIdLst>
             <p14:sldId id="272"/>
             <p14:sldId id="273"/>
@@ -178,19 +178,19 @@
             <p14:sldId id="276"/>
           </p14:sldIdLst>
         </p14:section>
-        <p14:section name="Demo 3 - Fresh context" id="{ae5843b7-c474-07a9-59c2-559d2150c4e5}">
+        <p14:section name="Demo 3 - Fresh context" id="{b8a21e0f-5cc4-160e-5dc7-d6902efe4aa4}">
           <p14:sldIdLst>
             <p14:sldId id="277"/>
           </p14:sldIdLst>
         </p14:section>
-        <p14:section name="Close" id="{fc53ddf9-1d88-7cb5-509f-45d21a63f8f9}">
+        <p14:section name="Close" id="{3f4e8706-5a6c-380f-4306-ad645066b4e5}">
           <p14:sldIdLst>
             <p14:sldId id="278"/>
             <p14:sldId id="279"/>
             <p14:sldId id="280"/>
           </p14:sldIdLst>
         </p14:section>
-        <p14:section name="Backup" id="{cf46c551-a743-51a0-74d5-10434a08dc4f}">
+        <p14:section name="Backup" id="{7dfc6d74-82bd-f17d-39c2-ec0259afd3c3}">
           <p14:sldIdLst>
             <p14:sldId id="281"/>
             <p14:sldId id="282"/>
@@ -25913,7 +25913,7 @@
                   <a:schemeClr val="tx1"/>
                 </a:solidFill>
               </a:rPr>
-              <a:t>The repository is booby-trapped like a real one</a:t>
+              <a:t>Like any real codebase, some files look more relevant than they are</a:t>
             </a:r>
             <a:endParaRPr lang="en-US" sz="1800" dirty="0"/>
           </a:p>

</xml_diff>

<commit_message>
Score the race and slide 23 on slide 7's scorecard
Slide 7 promises six measures; the race scoreboard and slide 23 reported a
different mix (no corrections or unrelated-changes row on slide 23, and
"context % at the end" where the race measures peak context).

- race.mjs: scoreboard leads with slide 7's six measures under the same
  labels (correctness first), then the slide 6 costs, then diagnostics.
- Slide 7: "Context % at the end" becomes "Peak context", which is what the
  race measures and the better signal anyway.
- Slide 23: the same six rows plus cost, from the 13 Oct rehearsal run.

Co-Authored-By: Claude Opus 5.5 (1M context) <noreply@anthropic.com>
</commit_message>
<xml_diff>
--- a/presentation/vibe-vs-verified.pptx
+++ b/presentation/vibe-vs-verified.pptx
@@ -133,14 +133,14 @@
   <p:extLst>
     <p:ext uri="{521415D9-36F7-43E2-AB2F-B90AF26B5E84}">
       <p14:sectionLst xmlns:p14="http://schemas.microsoft.com/office/powerpoint/2010/main">
-        <p14:section name="Open" id="{32ad6a66-5285-74b9-1956-6aa2e5ea2a40}">
+        <p14:section name="Open" id="{789b8d8d-e3e0-06ac-c15d-38a95d7ee0c4}">
           <p14:sldIdLst>
             <p14:sldId id="256"/>
             <p14:sldId id="257"/>
             <p14:sldId id="258"/>
           </p14:sldIdLst>
         </p14:section>
-        <p14:section name="Theory 1 - Context" id="{078abeba-5bb7-c4bd-939d-978f9a5a6a86}">
+        <p14:section name="Theory 1 - Context" id="{acf9d185-8139-197b-affa-774700d5340a}">
           <p14:sldIdLst>
             <p14:sldId id="259"/>
             <p14:sldId id="260"/>
@@ -148,12 +148,12 @@
             <p14:sldId id="262"/>
           </p14:sldIdLst>
         </p14:section>
-        <p14:section name="Demo 1 - Vibe" id="{37d71a93-590f-78f6-5788-d22bfa953bcc}">
+        <p14:section name="Demo 1 - Vibe" id="{accfaffd-5de8-50de-f0b5-c9a47e89844e}">
           <p14:sldIdLst>
             <p14:sldId id="263"/>
           </p14:sldIdLst>
         </p14:section>
-        <p14:section name="Theory 2 - Planning" id="{5e19671c-488b-0c40-71c8-9c585c9acef4}">
+        <p14:section name="Theory 2 - Planning" id="{c17ef911-466b-e80a-cba3-991b33c966f1}">
           <p14:sldIdLst>
             <p14:sldId id="264"/>
             <p14:sldId id="265"/>
@@ -164,12 +164,12 @@
             <p14:sldId id="270"/>
           </p14:sldIdLst>
         </p14:section>
-        <p14:section name="Demo 2 - Disciplined" id="{09d0afa8-3a22-02ba-4171-b1046c7cecdc}">
+        <p14:section name="Demo 2 - Disciplined" id="{7180e49b-4be7-f226-41c0-7c6e0abb1fcd}">
           <p14:sldIdLst>
             <p14:sldId id="271"/>
           </p14:sldIdLst>
         </p14:section>
-        <p14:section name="Theory 3 - Context" id="{a33524fc-9568-8f31-e237-d448f50f2485}">
+        <p14:section name="Theory 3 - Context" id="{9d293e56-dd82-98b3-e0d5-412a006f7f2a}">
           <p14:sldIdLst>
             <p14:sldId id="272"/>
             <p14:sldId id="273"/>
@@ -178,19 +178,19 @@
             <p14:sldId id="276"/>
           </p14:sldIdLst>
         </p14:section>
-        <p14:section name="Demo 3 - Fresh context" id="{b8a21e0f-5cc4-160e-5dc7-d6902efe4aa4}">
+        <p14:section name="Demo 3 - Fresh context" id="{59f82a3e-9576-eeca-7a89-87bc01b9d90a}">
           <p14:sldIdLst>
             <p14:sldId id="277"/>
           </p14:sldIdLst>
         </p14:section>
-        <p14:section name="Close" id="{3f4e8706-5a6c-380f-4306-ad645066b4e5}">
+        <p14:section name="Close" id="{3f67a1d1-69c8-c2dd-c4e0-81fea9e02aec}">
           <p14:sldIdLst>
             <p14:sldId id="278"/>
             <p14:sldId id="279"/>
             <p14:sldId id="280"/>
           </p14:sldIdLst>
         </p14:section>
-        <p14:section name="Backup" id="{7dfc6d74-82bd-f17d-39c2-ec0259afd3c3}">
+        <p14:section name="Backup" id="{2f6ed937-ddb1-0b8e-f159-49203a8ed82d}">
           <p14:sldIdLst>
             <p14:sldId id="281"/>
             <p14:sldId id="282"/>
@@ -1920,7 +1920,7 @@
           <a:p>
             <a:r>
               <a:rPr lang="en-US" dirty="0"/>
-              <a:t>BOTH. Eugene switches to the race terminal - the scoreboard prints when both lanes finish (results also saved in demo-kit/results/). Adam reads the rows top-down: correctness first, then tokens and context, then files. The numbers on this slide are from a rehearsal run - the fallback if the live race hasn't finished; say so if you use them. The failed vibe task is free shipping: 'over £100' became '&gt; 10000' and express went free too. Then cost and context: a third more spend for a worse result. Files read is a wash on this repo - good docs keep both lanes on the right files - so don't oversell it.</a:t>
+              <a:t>BOTH. Eugene switches to the race terminal - the scoreboard prints when both lanes finish (results also saved in demo-kit/results/). Adam reads the rows top-down: they are slide 7's six scorecard measures, correctness first, then cost. The numbers on this slide are from a rehearsal run - the fallback if the live race hasn't finished; say so if you use them. The failed vibe task is free shipping: 'over £100' became '&gt; 10000' and express went free too. Then cost and context: a third more spend for a worse result. Files read is a wash on this repo - good docs keep both lanes on the right files - so don't oversell it.</a:t>
             </a:r>
             <a:endParaRPr lang="en-US" dirty="0"/>
           </a:p>
@@ -17613,7 +17613,7 @@
                 <a:gridCol w="1828800"/>
                 <a:gridCol w="1828800"/>
               </a:tblGrid>
-              <a:tr h="512064">
+              <a:tr h="457200">
                 <a:tc>
                   <a:txBody>
                     <a:bodyPr/>
@@ -17623,14 +17623,14 @@
                         <a:buNone/>
                       </a:pPr>
                       <a:r>
-                        <a:rPr lang="en-US" sz="1500" b="1" dirty="0">
+                        <a:rPr lang="en-US" sz="1400" b="1" dirty="0">
                           <a:solidFill>
                             <a:schemeClr val="bg1"/>
                           </a:solidFill>
                         </a:rPr>
                         <a:t>Metric</a:t>
                       </a:r>
-                      <a:endParaRPr lang="en-US" sz="1500" dirty="0"/>
+                      <a:endParaRPr lang="en-US" sz="1400" dirty="0"/>
                     </a:p>
                   </a:txBody>
                   <a:tcPr marL="128016" marR="128016" marT="36576" marB="36576" anchor="ctr">
@@ -17684,14 +17684,14 @@
                         <a:buNone/>
                       </a:pPr>
                       <a:r>
-                        <a:rPr lang="en-US" sz="1500" b="1" dirty="0">
+                        <a:rPr lang="en-US" sz="1400" b="1" dirty="0">
                           <a:solidFill>
                             <a:schemeClr val="bg1"/>
                           </a:solidFill>
                         </a:rPr>
                         <a:t>Vibe</a:t>
                       </a:r>
-                      <a:endParaRPr lang="en-US" sz="1500" dirty="0"/>
+                      <a:endParaRPr lang="en-US" sz="1400" dirty="0"/>
                     </a:p>
                   </a:txBody>
                   <a:tcPr marL="128016" marR="128016" marT="36576" marB="36576" anchor="ctr">
@@ -17745,14 +17745,14 @@
                         <a:buNone/>
                       </a:pPr>
                       <a:r>
-                        <a:rPr lang="en-US" sz="1500" b="1" dirty="0">
+                        <a:rPr lang="en-US" sz="1400" b="1" dirty="0">
                           <a:solidFill>
                             <a:schemeClr val="bg1"/>
                           </a:solidFill>
                         </a:rPr>
                         <a:t>Disciplined</a:t>
                       </a:r>
-                      <a:endParaRPr lang="en-US" sz="1500" dirty="0"/>
+                      <a:endParaRPr lang="en-US" sz="1400" dirty="0"/>
                     </a:p>
                   </a:txBody>
                   <a:tcPr marL="128016" marR="128016" marT="36576" marB="36576" anchor="ctr">
@@ -17798,7 +17798,7 @@
                   </a:tcPr>
                 </a:tc>
               </a:tr>
-              <a:tr h="512064">
+              <a:tr h="457200">
                 <a:tc>
                   <a:txBody>
                     <a:bodyPr/>
@@ -17808,14 +17808,14 @@
                         <a:buNone/>
                       </a:pPr>
                       <a:r>
-                        <a:rPr lang="en-US" sz="1500" b="1" dirty="0">
+                        <a:rPr lang="en-US" sz="1400" b="1" dirty="0">
                           <a:solidFill>
                             <a:schemeClr val="tx1"/>
                           </a:solidFill>
                         </a:rPr>
-                        <a:t>Tasks that passed hidden verification</a:t>
+                        <a:t>Hidden verification passed</a:t>
                       </a:r>
-                      <a:endParaRPr lang="en-US" sz="1500" dirty="0"/>
+                      <a:endParaRPr lang="en-US" sz="1400" dirty="0"/>
                     </a:p>
                   </a:txBody>
                   <a:tcPr marL="128016" marR="128016" marT="36576" marB="36576" anchor="ctr">
@@ -17866,14 +17866,14 @@
                         <a:buNone/>
                       </a:pPr>
                       <a:r>
-                        <a:rPr lang="en-US" sz="1500" dirty="0">
+                        <a:rPr lang="en-US" sz="1400" dirty="0">
                           <a:solidFill>
                             <a:schemeClr val="tx1"/>
                           </a:solidFill>
                         </a:rPr>
                         <a:t>2 / 3</a:t>
                       </a:r>
-                      <a:endParaRPr lang="en-US" sz="1500" dirty="0"/>
+                      <a:endParaRPr lang="en-US" sz="1400" dirty="0"/>
                     </a:p>
                   </a:txBody>
                   <a:tcPr marL="128016" marR="128016" marT="36576" marB="36576" anchor="ctr">
@@ -17924,14 +17924,14 @@
                         <a:buNone/>
                       </a:pPr>
                       <a:r>
-                        <a:rPr lang="en-US" sz="1500" dirty="0">
+                        <a:rPr lang="en-US" sz="1400" dirty="0">
                           <a:solidFill>
                             <a:schemeClr val="tx1"/>
                           </a:solidFill>
                         </a:rPr>
                         <a:t>3 / 3</a:t>
                       </a:r>
-                      <a:endParaRPr lang="en-US" sz="1500" dirty="0"/>
+                      <a:endParaRPr lang="en-US" sz="1400" dirty="0"/>
                     </a:p>
                   </a:txBody>
                   <a:tcPr marL="128016" marR="128016" marT="36576" marB="36576" anchor="ctr">
@@ -17974,7 +17974,7 @@
                   </a:tcPr>
                 </a:tc>
               </a:tr>
-              <a:tr h="512064">
+              <a:tr h="457200">
                 <a:tc>
                   <a:txBody>
                     <a:bodyPr/>
@@ -17984,14 +17984,14 @@
                         <a:buNone/>
                       </a:pPr>
                       <a:r>
-                        <a:rPr lang="en-US" sz="1500" b="1" dirty="0">
+                        <a:rPr lang="en-US" sz="1400" b="1" dirty="0">
                           <a:solidFill>
                             <a:schemeClr val="tx1"/>
                           </a:solidFill>
                         </a:rPr>
-                        <a:t>Tokens processed</a:t>
+                        <a:t>Files read / files that mattered</a:t>
                       </a:r>
-                      <a:endParaRPr lang="en-US" sz="1500" dirty="0"/>
+                      <a:endParaRPr lang="en-US" sz="1400" dirty="0"/>
                     </a:p>
                   </a:txBody>
                   <a:tcPr marL="128016" marR="128016" marT="36576" marB="36576" anchor="ctr">
@@ -18042,14 +18042,14 @@
                         <a:buNone/>
                       </a:pPr>
                       <a:r>
-                        <a:rPr lang="en-US" sz="1500" dirty="0">
+                        <a:rPr lang="en-US" sz="1400" dirty="0">
                           <a:solidFill>
                             <a:schemeClr val="tx1"/>
                           </a:solidFill>
                         </a:rPr>
-                        <a:t>907k</a:t>
+                        <a:t>7 / 7</a:t>
                       </a:r>
-                      <a:endParaRPr lang="en-US" sz="1500" dirty="0"/>
+                      <a:endParaRPr lang="en-US" sz="1400" dirty="0"/>
                     </a:p>
                   </a:txBody>
                   <a:tcPr marL="128016" marR="128016" marT="36576" marB="36576" anchor="ctr">
@@ -18100,14 +18100,14 @@
                         <a:buNone/>
                       </a:pPr>
                       <a:r>
-                        <a:rPr lang="en-US" sz="1500" dirty="0">
+                        <a:rPr lang="en-US" sz="1400" dirty="0">
                           <a:solidFill>
                             <a:schemeClr val="tx1"/>
                           </a:solidFill>
                         </a:rPr>
-                        <a:t>729k</a:t>
+                        <a:t>9 / 8</a:t>
                       </a:r>
-                      <a:endParaRPr lang="en-US" sz="1500" dirty="0"/>
+                      <a:endParaRPr lang="en-US" sz="1400" dirty="0"/>
                     </a:p>
                   </a:txBody>
                   <a:tcPr marL="128016" marR="128016" marT="36576" marB="36576" anchor="ctr">
@@ -18150,7 +18150,7 @@
                   </a:tcPr>
                 </a:tc>
               </a:tr>
-              <a:tr h="512064">
+              <a:tr h="457200">
                 <a:tc>
                   <a:txBody>
                     <a:bodyPr/>
@@ -18160,14 +18160,14 @@
                         <a:buNone/>
                       </a:pPr>
                       <a:r>
-                        <a:rPr lang="en-US" sz="1500" b="1" dirty="0">
+                        <a:rPr lang="en-US" sz="1400" b="1" dirty="0">
                           <a:solidFill>
                             <a:schemeClr val="tx1"/>
                           </a:solidFill>
                         </a:rPr>
-                        <a:t>Peak context</a:t>
+                        <a:t>Prompts (corrections)</a:t>
                       </a:r>
-                      <a:endParaRPr lang="en-US" sz="1500" dirty="0"/>
+                      <a:endParaRPr lang="en-US" sz="1400" dirty="0"/>
                     </a:p>
                   </a:txBody>
                   <a:tcPr marL="128016" marR="128016" marT="36576" marB="36576" anchor="ctr">
@@ -18218,14 +18218,14 @@
                         <a:buNone/>
                       </a:pPr>
                       <a:r>
-                        <a:rPr lang="en-US" sz="1500" dirty="0">
+                        <a:rPr lang="en-US" sz="1400" dirty="0">
                           <a:solidFill>
                             <a:schemeClr val="tx1"/>
                           </a:solidFill>
                         </a:rPr>
-                        <a:t>60.0k</a:t>
+                        <a:t>3 (0)</a:t>
                       </a:r>
-                      <a:endParaRPr lang="en-US" sz="1500" dirty="0"/>
+                      <a:endParaRPr lang="en-US" sz="1400" dirty="0"/>
                     </a:p>
                   </a:txBody>
                   <a:tcPr marL="128016" marR="128016" marT="36576" marB="36576" anchor="ctr">
@@ -18276,14 +18276,14 @@
                         <a:buNone/>
                       </a:pPr>
                       <a:r>
-                        <a:rPr lang="en-US" sz="1500" dirty="0">
+                        <a:rPr lang="en-US" sz="1400" dirty="0">
                           <a:solidFill>
                             <a:schemeClr val="tx1"/>
                           </a:solidFill>
                         </a:rPr>
-                        <a:t>51.3k</a:t>
+                        <a:t>3 (0)</a:t>
                       </a:r>
-                      <a:endParaRPr lang="en-US" sz="1500" dirty="0"/>
+                      <a:endParaRPr lang="en-US" sz="1400" dirty="0"/>
                     </a:p>
                   </a:txBody>
                   <a:tcPr marL="128016" marR="128016" marT="36576" marB="36576" anchor="ctr">
@@ -18326,7 +18326,7 @@
                   </a:tcPr>
                 </a:tc>
               </a:tr>
-              <a:tr h="512064">
+              <a:tr h="457200">
                 <a:tc>
                   <a:txBody>
                     <a:bodyPr/>
@@ -18336,14 +18336,14 @@
                         <a:buNone/>
                       </a:pPr>
                       <a:r>
-                        <a:rPr lang="en-US" sz="1500" b="1" dirty="0">
+                        <a:rPr lang="en-US" sz="1400" b="1" dirty="0">
                           <a:solidFill>
                             <a:schemeClr val="tx1"/>
                           </a:solidFill>
                         </a:rPr>
-                        <a:t>Cost</a:t>
+                        <a:t>Full / focused test runs</a:t>
                       </a:r>
-                      <a:endParaRPr lang="en-US" sz="1500" dirty="0"/>
+                      <a:endParaRPr lang="en-US" sz="1400" dirty="0"/>
                     </a:p>
                   </a:txBody>
                   <a:tcPr marL="128016" marR="128016" marT="36576" marB="36576" anchor="ctr">
@@ -18394,14 +18394,14 @@
                         <a:buNone/>
                       </a:pPr>
                       <a:r>
-                        <a:rPr lang="en-US" sz="1500" dirty="0">
+                        <a:rPr lang="en-US" sz="1400" dirty="0">
                           <a:solidFill>
                             <a:schemeClr val="tx1"/>
                           </a:solidFill>
                         </a:rPr>
-                        <a:t>$0.90</a:t>
+                        <a:t>5 / 0</a:t>
                       </a:r>
-                      <a:endParaRPr lang="en-US" sz="1500" dirty="0"/>
+                      <a:endParaRPr lang="en-US" sz="1400" dirty="0"/>
                     </a:p>
                   </a:txBody>
                   <a:tcPr marL="128016" marR="128016" marT="36576" marB="36576" anchor="ctr">
@@ -18452,14 +18452,14 @@
                         <a:buNone/>
                       </a:pPr>
                       <a:r>
-                        <a:rPr lang="en-US" sz="1500" dirty="0">
+                        <a:rPr lang="en-US" sz="1400" dirty="0">
                           <a:solidFill>
                             <a:schemeClr val="tx1"/>
                           </a:solidFill>
                         </a:rPr>
-                        <a:t>$0.60</a:t>
+                        <a:t>0 / 3</a:t>
                       </a:r>
-                      <a:endParaRPr lang="en-US" sz="1500" dirty="0"/>
+                      <a:endParaRPr lang="en-US" sz="1400" dirty="0"/>
                     </a:p>
                   </a:txBody>
                   <a:tcPr marL="128016" marR="128016" marT="36576" marB="36576" anchor="ctr">
@@ -18502,7 +18502,7 @@
                   </a:tcPr>
                 </a:tc>
               </a:tr>
-              <a:tr h="512064">
+              <a:tr h="457200">
                 <a:tc>
                   <a:txBody>
                     <a:bodyPr/>
@@ -18512,14 +18512,14 @@
                         <a:buNone/>
                       </a:pPr>
                       <a:r>
-                        <a:rPr lang="en-US" sz="1500" b="1" dirty="0">
+                        <a:rPr lang="en-US" sz="1400" b="1" dirty="0">
                           <a:solidFill>
                             <a:schemeClr val="tx1"/>
                           </a:solidFill>
                         </a:rPr>
-                        <a:t>Full / focused test runs</a:t>
+                        <a:t>Files changed that didn't need to</a:t>
                       </a:r>
-                      <a:endParaRPr lang="en-US" sz="1500" dirty="0"/>
+                      <a:endParaRPr lang="en-US" sz="1400" dirty="0"/>
                     </a:p>
                   </a:txBody>
                   <a:tcPr marL="128016" marR="128016" marT="36576" marB="36576" anchor="ctr">
@@ -18570,14 +18570,14 @@
                         <a:buNone/>
                       </a:pPr>
                       <a:r>
-                        <a:rPr lang="en-US" sz="1500" dirty="0">
+                        <a:rPr lang="en-US" sz="1400" dirty="0">
                           <a:solidFill>
                             <a:schemeClr val="tx1"/>
                           </a:solidFill>
                         </a:rPr>
-                        <a:t>5 / 0</a:t>
+                        <a:t>1</a:t>
                       </a:r>
-                      <a:endParaRPr lang="en-US" sz="1500" dirty="0"/>
+                      <a:endParaRPr lang="en-US" sz="1400" dirty="0"/>
                     </a:p>
                   </a:txBody>
                   <a:tcPr marL="128016" marR="128016" marT="36576" marB="36576" anchor="ctr">
@@ -18628,14 +18628,14 @@
                         <a:buNone/>
                       </a:pPr>
                       <a:r>
-                        <a:rPr lang="en-US" sz="1500" dirty="0">
+                        <a:rPr lang="en-US" sz="1400" dirty="0">
                           <a:solidFill>
                             <a:schemeClr val="tx1"/>
                           </a:solidFill>
                         </a:rPr>
-                        <a:t>0 / 3</a:t>
+                        <a:t>1</a:t>
                       </a:r>
-                      <a:endParaRPr lang="en-US" sz="1500" dirty="0"/>
+                      <a:endParaRPr lang="en-US" sz="1400" dirty="0"/>
                     </a:p>
                   </a:txBody>
                   <a:tcPr marL="128016" marR="128016" marT="36576" marB="36576" anchor="ctr">
@@ -18678,7 +18678,7 @@
                   </a:tcPr>
                 </a:tc>
               </a:tr>
-              <a:tr h="512064">
+              <a:tr h="457200">
                 <a:tc>
                   <a:txBody>
                     <a:bodyPr/>
@@ -18688,14 +18688,14 @@
                         <a:buNone/>
                       </a:pPr>
                       <a:r>
-                        <a:rPr lang="en-US" sz="1500" b="1" dirty="0">
+                        <a:rPr lang="en-US" sz="1400" b="1" dirty="0">
                           <a:solidFill>
                             <a:schemeClr val="tx1"/>
                           </a:solidFill>
                         </a:rPr>
-                        <a:t>Files read · relevant ratio</a:t>
+                        <a:t>Peak context</a:t>
                       </a:r>
-                      <a:endParaRPr lang="en-US" sz="1500" dirty="0"/>
+                      <a:endParaRPr lang="en-US" sz="1400" dirty="0"/>
                     </a:p>
                   </a:txBody>
                   <a:tcPr marL="128016" marR="128016" marT="36576" marB="36576" anchor="ctr">
@@ -18746,14 +18746,14 @@
                         <a:buNone/>
                       </a:pPr>
                       <a:r>
-                        <a:rPr lang="en-US" sz="1500" dirty="0">
+                        <a:rPr lang="en-US" sz="1400" dirty="0">
                           <a:solidFill>
                             <a:schemeClr val="tx1"/>
                           </a:solidFill>
                         </a:rPr>
-                        <a:t>7 · 100%</a:t>
+                        <a:t>60.0k</a:t>
                       </a:r>
-                      <a:endParaRPr lang="en-US" sz="1500" dirty="0"/>
+                      <a:endParaRPr lang="en-US" sz="1400" dirty="0"/>
                     </a:p>
                   </a:txBody>
                   <a:tcPr marL="128016" marR="128016" marT="36576" marB="36576" anchor="ctr">
@@ -18804,14 +18804,14 @@
                         <a:buNone/>
                       </a:pPr>
                       <a:r>
-                        <a:rPr lang="en-US" sz="1500" dirty="0">
+                        <a:rPr lang="en-US" sz="1400" dirty="0">
                           <a:solidFill>
                             <a:schemeClr val="tx1"/>
                           </a:solidFill>
                         </a:rPr>
-                        <a:t>9 · 89%</a:t>
+                        <a:t>51.3k</a:t>
                       </a:r>
-                      <a:endParaRPr lang="en-US" sz="1500" dirty="0"/>
+                      <a:endParaRPr lang="en-US" sz="1400" dirty="0"/>
                     </a:p>
                   </a:txBody>
                   <a:tcPr marL="128016" marR="128016" marT="36576" marB="36576" anchor="ctr">
@@ -18854,7 +18854,7 @@
                   </a:tcPr>
                 </a:tc>
               </a:tr>
-              <a:tr h="512064">
+              <a:tr h="457200">
                 <a:tc>
                   <a:txBody>
                     <a:bodyPr/>
@@ -18864,14 +18864,14 @@
                         <a:buNone/>
                       </a:pPr>
                       <a:r>
-                        <a:rPr lang="en-US" sz="1500" b="1" dirty="0">
+                        <a:rPr lang="en-US" sz="1400" b="1" dirty="0">
                           <a:solidFill>
                             <a:schemeClr val="tx1"/>
                           </a:solidFill>
                         </a:rPr>
-                        <a:t>Agent minutes</a:t>
+                        <a:t>Cost · tokens processed</a:t>
                       </a:r>
-                      <a:endParaRPr lang="en-US" sz="1500" dirty="0"/>
+                      <a:endParaRPr lang="en-US" sz="1400" dirty="0"/>
                     </a:p>
                   </a:txBody>
                   <a:tcPr marL="128016" marR="128016" marT="36576" marB="36576" anchor="ctr">
@@ -18922,14 +18922,14 @@
                         <a:buNone/>
                       </a:pPr>
                       <a:r>
-                        <a:rPr lang="en-US" sz="1500" dirty="0">
+                        <a:rPr lang="en-US" sz="1400" dirty="0">
                           <a:solidFill>
                             <a:schemeClr val="tx1"/>
                           </a:solidFill>
                         </a:rPr>
-                        <a:t>2.2</a:t>
+                        <a:t>$0.90 · 907k</a:t>
                       </a:r>
-                      <a:endParaRPr lang="en-US" sz="1500" dirty="0"/>
+                      <a:endParaRPr lang="en-US" sz="1400" dirty="0"/>
                     </a:p>
                   </a:txBody>
                   <a:tcPr marL="128016" marR="128016" marT="36576" marB="36576" anchor="ctr">
@@ -18980,14 +18980,190 @@
                         <a:buNone/>
                       </a:pPr>
                       <a:r>
-                        <a:rPr lang="en-US" sz="1500" dirty="0">
+                        <a:rPr lang="en-US" sz="1400" dirty="0">
+                          <a:solidFill>
+                            <a:schemeClr val="tx1"/>
+                          </a:solidFill>
+                        </a:rPr>
+                        <a:t>$0.60 · 729k</a:t>
+                      </a:r>
+                      <a:endParaRPr lang="en-US" sz="1400" dirty="0"/>
+                    </a:p>
+                  </a:txBody>
+                  <a:tcPr marL="128016" marR="128016" marT="36576" marB="36576" anchor="ctr">
+                    <a:lnL w="12700" cap="flat" cmpd="sng" algn="ctr">
+                      <a:solidFill>
+                        <a:srgbClr val="EAF0F4"/>
+                      </a:solidFill>
+                      <a:prstDash val="solid"/>
+                      <a:round/>
+                      <a:headEnd type="none" w="med" len="med"/>
+                      <a:tailEnd type="none" w="med" len="med"/>
+                    </a:lnL>
+                    <a:lnR w="12700" cap="flat" cmpd="sng" algn="ctr">
+                      <a:solidFill>
+                        <a:srgbClr val="EAF0F4"/>
+                      </a:solidFill>
+                      <a:prstDash val="solid"/>
+                      <a:round/>
+                      <a:headEnd type="none" w="med" len="med"/>
+                      <a:tailEnd type="none" w="med" len="med"/>
+                    </a:lnR>
+                    <a:lnT w="12700" cap="flat" cmpd="sng" algn="ctr">
+                      <a:solidFill>
+                        <a:srgbClr val="EAF0F4"/>
+                      </a:solidFill>
+                      <a:prstDash val="solid"/>
+                      <a:round/>
+                      <a:headEnd type="none" w="med" len="med"/>
+                      <a:tailEnd type="none" w="med" len="med"/>
+                    </a:lnT>
+                    <a:lnB w="12700" cap="flat" cmpd="sng" algn="ctr">
+                      <a:solidFill>
+                        <a:srgbClr val="EAF0F4"/>
+                      </a:solidFill>
+                      <a:prstDash val="solid"/>
+                      <a:round/>
+                      <a:headEnd type="none" w="med" len="med"/>
+                      <a:tailEnd type="none" w="med" len="med"/>
+                    </a:lnB>
+                  </a:tcPr>
+                </a:tc>
+              </a:tr>
+              <a:tr h="457200">
+                <a:tc>
+                  <a:txBody>
+                    <a:bodyPr/>
+                    <a:lstStyle/>
+                    <a:p>
+                      <a:pPr indent="0" marL="0">
+                        <a:buNone/>
+                      </a:pPr>
+                      <a:r>
+                        <a:rPr lang="en-US" sz="1400" b="1" dirty="0">
+                          <a:solidFill>
+                            <a:schemeClr val="tx1"/>
+                          </a:solidFill>
+                        </a:rPr>
+                        <a:t>Agent minutes</a:t>
+                      </a:r>
+                      <a:endParaRPr lang="en-US" sz="1400" dirty="0"/>
+                    </a:p>
+                  </a:txBody>
+                  <a:tcPr marL="128016" marR="128016" marT="36576" marB="36576" anchor="ctr">
+                    <a:lnL w="12700" cap="flat" cmpd="sng" algn="ctr">
+                      <a:solidFill>
+                        <a:srgbClr val="EAF0F4"/>
+                      </a:solidFill>
+                      <a:prstDash val="solid"/>
+                      <a:round/>
+                      <a:headEnd type="none" w="med" len="med"/>
+                      <a:tailEnd type="none" w="med" len="med"/>
+                    </a:lnL>
+                    <a:lnR w="12700" cap="flat" cmpd="sng" algn="ctr">
+                      <a:solidFill>
+                        <a:srgbClr val="EAF0F4"/>
+                      </a:solidFill>
+                      <a:prstDash val="solid"/>
+                      <a:round/>
+                      <a:headEnd type="none" w="med" len="med"/>
+                      <a:tailEnd type="none" w="med" len="med"/>
+                    </a:lnR>
+                    <a:lnT w="12700" cap="flat" cmpd="sng" algn="ctr">
+                      <a:solidFill>
+                        <a:srgbClr val="EAF0F4"/>
+                      </a:solidFill>
+                      <a:prstDash val="solid"/>
+                      <a:round/>
+                      <a:headEnd type="none" w="med" len="med"/>
+                      <a:tailEnd type="none" w="med" len="med"/>
+                    </a:lnT>
+                    <a:lnB w="12700" cap="flat" cmpd="sng" algn="ctr">
+                      <a:solidFill>
+                        <a:srgbClr val="EAF0F4"/>
+                      </a:solidFill>
+                      <a:prstDash val="solid"/>
+                      <a:round/>
+                      <a:headEnd type="none" w="med" len="med"/>
+                      <a:tailEnd type="none" w="med" len="med"/>
+                    </a:lnB>
+                  </a:tcPr>
+                </a:tc>
+                <a:tc>
+                  <a:txBody>
+                    <a:bodyPr/>
+                    <a:lstStyle/>
+                    <a:p>
+                      <a:pPr algn="ctr" indent="0" marL="0">
+                        <a:buNone/>
+                      </a:pPr>
+                      <a:r>
+                        <a:rPr lang="en-US" sz="1400" dirty="0">
+                          <a:solidFill>
+                            <a:schemeClr val="tx1"/>
+                          </a:solidFill>
+                        </a:rPr>
+                        <a:t>2.2</a:t>
+                      </a:r>
+                      <a:endParaRPr lang="en-US" sz="1400" dirty="0"/>
+                    </a:p>
+                  </a:txBody>
+                  <a:tcPr marL="128016" marR="128016" marT="36576" marB="36576" anchor="ctr">
+                    <a:lnL w="12700" cap="flat" cmpd="sng" algn="ctr">
+                      <a:solidFill>
+                        <a:srgbClr val="EAF0F4"/>
+                      </a:solidFill>
+                      <a:prstDash val="solid"/>
+                      <a:round/>
+                      <a:headEnd type="none" w="med" len="med"/>
+                      <a:tailEnd type="none" w="med" len="med"/>
+                    </a:lnL>
+                    <a:lnR w="12700" cap="flat" cmpd="sng" algn="ctr">
+                      <a:solidFill>
+                        <a:srgbClr val="EAF0F4"/>
+                      </a:solidFill>
+                      <a:prstDash val="solid"/>
+                      <a:round/>
+                      <a:headEnd type="none" w="med" len="med"/>
+                      <a:tailEnd type="none" w="med" len="med"/>
+                    </a:lnR>
+                    <a:lnT w="12700" cap="flat" cmpd="sng" algn="ctr">
+                      <a:solidFill>
+                        <a:srgbClr val="EAF0F4"/>
+                      </a:solidFill>
+                      <a:prstDash val="solid"/>
+                      <a:round/>
+                      <a:headEnd type="none" w="med" len="med"/>
+                      <a:tailEnd type="none" w="med" len="med"/>
+                    </a:lnT>
+                    <a:lnB w="12700" cap="flat" cmpd="sng" algn="ctr">
+                      <a:solidFill>
+                        <a:srgbClr val="EAF0F4"/>
+                      </a:solidFill>
+                      <a:prstDash val="solid"/>
+                      <a:round/>
+                      <a:headEnd type="none" w="med" len="med"/>
+                      <a:tailEnd type="none" w="med" len="med"/>
+                    </a:lnB>
+                  </a:tcPr>
+                </a:tc>
+                <a:tc>
+                  <a:txBody>
+                    <a:bodyPr/>
+                    <a:lstStyle/>
+                    <a:p>
+                      <a:pPr algn="ctr" indent="0" marL="0">
+                        <a:buNone/>
+                      </a:pPr>
+                      <a:r>
+                        <a:rPr lang="en-US" sz="1400" dirty="0">
                           <a:solidFill>
                             <a:schemeClr val="tx1"/>
                           </a:solidFill>
                         </a:rPr>
                         <a:t>1.7</a:t>
                       </a:r>
-                      <a:endParaRPr lang="en-US" sz="1500" dirty="0"/>
+                      <a:endParaRPr lang="en-US" sz="1400" dirty="0"/>
                     </a:p>
                   </a:txBody>
                   <a:tcPr marL="128016" marR="128016" marT="36576" marB="36576" anchor="ctr">
@@ -27699,7 +27875,7 @@
                             <a:schemeClr val="tx1"/>
                           </a:solidFill>
                         </a:rPr>
-                        <a:t>Context % at the end</a:t>
+                        <a:t>Peak context</a:t>
                       </a:r>
                       <a:endParaRPr lang="en-US" sz="1400" dirty="0"/>
                     </a:p>
@@ -27757,7 +27933,7 @@
                             <a:schemeClr val="tx1"/>
                           </a:solidFill>
                         </a:rPr>
-                        <a:t>Claude Code: /context · Cursor CLI: context % status line</a:t>
+                        <a:t>/context or the status line · Cursor: context % status line</a:t>
                       </a:r>
                       <a:endParaRPr lang="en-US" sz="1400" dirty="0"/>
                     </a:p>

</xml_diff>

<commit_message>
Rebuild the deck for the four-ticket race and QA round
Co-Authored-By: Claude Opus 5.5 (1M context) <noreply@anthropic.com>
</commit_message>
<xml_diff>
--- a/presentation/vibe-vs-verified.pptx
+++ b/presentation/vibe-vs-verified.pptx
@@ -133,14 +133,14 @@
   <p:extLst>
     <p:ext uri="{521415D9-36F7-43E2-AB2F-B90AF26B5E84}">
       <p14:sectionLst xmlns:p14="http://schemas.microsoft.com/office/powerpoint/2010/main">
-        <p14:section name="Open" id="{789b8d8d-e3e0-06ac-c15d-38a95d7ee0c4}">
+        <p14:section name="Open" id="{9cc60ae2-a466-9c7c-af6f-6c379591c664}">
           <p14:sldIdLst>
             <p14:sldId id="256"/>
             <p14:sldId id="257"/>
             <p14:sldId id="258"/>
           </p14:sldIdLst>
         </p14:section>
-        <p14:section name="Theory 1 - Context" id="{acf9d185-8139-197b-affa-774700d5340a}">
+        <p14:section name="Theory 1 - Context" id="{60a0d2ef-ceb5-80c9-c8fe-15ecc5967089}">
           <p14:sldIdLst>
             <p14:sldId id="259"/>
             <p14:sldId id="260"/>
@@ -148,12 +148,12 @@
             <p14:sldId id="262"/>
           </p14:sldIdLst>
         </p14:section>
-        <p14:section name="Demo 1 - Vibe" id="{accfaffd-5de8-50de-f0b5-c9a47e89844e}">
+        <p14:section name="Demo 1 - Vibe" id="{e059ac13-4e8e-c914-293a-18d6f58d4982}">
           <p14:sldIdLst>
             <p14:sldId id="263"/>
           </p14:sldIdLst>
         </p14:section>
-        <p14:section name="Theory 2 - Planning" id="{c17ef911-466b-e80a-cba3-991b33c966f1}">
+        <p14:section name="Theory 2 - Planning" id="{0fdffc44-07d6-618c-6273-cd2c923180e4}">
           <p14:sldIdLst>
             <p14:sldId id="264"/>
             <p14:sldId id="265"/>
@@ -164,12 +164,12 @@
             <p14:sldId id="270"/>
           </p14:sldIdLst>
         </p14:section>
-        <p14:section name="Demo 2 - Disciplined" id="{7180e49b-4be7-f226-41c0-7c6e0abb1fcd}">
+        <p14:section name="Demo 2 - Disciplined" id="{07824460-252d-6005-f9ec-92c06a28ca5e}">
           <p14:sldIdLst>
             <p14:sldId id="271"/>
           </p14:sldIdLst>
         </p14:section>
-        <p14:section name="Theory 3 - Context" id="{9d293e56-dd82-98b3-e0d5-412a006f7f2a}">
+        <p14:section name="Theory 3 - Context" id="{c1f583f5-0416-715e-16dd-e90bce234bc3}">
           <p14:sldIdLst>
             <p14:sldId id="272"/>
             <p14:sldId id="273"/>
@@ -178,19 +178,19 @@
             <p14:sldId id="276"/>
           </p14:sldIdLst>
         </p14:section>
-        <p14:section name="Demo 3 - Fresh context" id="{59f82a3e-9576-eeca-7a89-87bc01b9d90a}">
+        <p14:section name="Demo 3 - Fresh context" id="{4f5337b5-2fda-9b92-5066-6167b9b7e151}">
           <p14:sldIdLst>
             <p14:sldId id="277"/>
           </p14:sldIdLst>
         </p14:section>
-        <p14:section name="Close" id="{3f67a1d1-69c8-c2dd-c4e0-81fea9e02aec}">
+        <p14:section name="Close" id="{8e7b8d7b-d199-c106-3d89-df6c32af8799}">
           <p14:sldIdLst>
             <p14:sldId id="278"/>
             <p14:sldId id="279"/>
             <p14:sldId id="280"/>
           </p14:sldIdLst>
         </p14:section>
-        <p14:section name="Backup" id="{2f6ed937-ddb1-0b8e-f159-49203a8ed82d}">
+        <p14:section name="Backup" id="{42bdc90e-1efb-5ca3-c15e-dab297950008}">
           <p14:sldIdLst>
             <p14:sldId id="281"/>
             <p14:sldId id="282"/>
@@ -1568,7 +1568,7 @@
           <a:p>
             <a:r>
               <a:rPr lang="en-US" dirty="0"/>
-              <a:t>ADAM. [Eugene starts `node race.mjs` on the second screen/terminal NOW if not already running.] Before we explain anything, we've started two Claude Code agents on the same three tickets in this repo. One gets prompts the way we all write them at 4pm on a Thursday. The other gets the habits we're about to teach. Same model. We'll come back at the end and see who finished, who was right, and what it cost.</a:t>
+              <a:t>ADAM. [Eugene starts `node race.mjs` on the second screen/terminal NOW if not already running.] Before we explain anything, we've started two Claude Code agents on the same four tickets in this repo. One gets prompts the way we all write them at 4pm on a Thursday. The other gets the habits we're about to teach. Same model. When both finish, QA checks the work and sends any failures back once - same report to both - because in real life a wrong answer comes back to you. We'll come back at the end and see who was right, and what it cost including the rework.</a:t>
             </a:r>
             <a:endParaRPr lang="en-US" dirty="0"/>
           </a:p>
@@ -1920,7 +1920,7 @@
           <a:p>
             <a:r>
               <a:rPr lang="en-US" dirty="0"/>
-              <a:t>BOTH. Eugene switches to the race terminal - the scoreboard prints when both lanes finish (results also saved in demo-kit/results/). Adam reads the rows top-down: they are slide 7's six scorecard measures, correctness first, then cost. The numbers on this slide are from a rehearsal run - the fallback if the live race hasn't finished; say so if you use them. The failed vibe task is free shipping: 'over £100' became '&gt; 10000' and express went free too. Then cost and context: a third more spend for a worse result. Files read is a wash on this repo - good docs keep both lanes on the right files - so don't oversell it.</a:t>
+              <a:t>BOTH. Eugene switches to the race terminal - the scoreboard prints when both lanes finish (results also saved in demo-kit/results/). Adam reads the rows top-down: they are slide 7's six scorecard measures, correctness first, then cost. The numbers on this slide are from a rehearsal run - the fallback if the live race hasn't finished; say so if you use them. The failed vibe task is free shipping: 'over £100' became '&gt; 10000' and express went free too. Then the QA round: the same failing-check report goes to both lanes; disciplined had nothing to fix, vibe needed a correction in its already-long chat. That rework is in the cost: about twice the spend and 40% more peak context for the same four tickets. Files read is even - good docs kept both lanes on the right files, which is Theory 3 working. Own it; it makes the rest credible.</a:t>
             </a:r>
             <a:endParaRPr lang="en-US" dirty="0"/>
           </a:p>
@@ -13844,7 +13844,7 @@
                   <a:schemeClr val="accent3"/>
                 </a:solidFill>
               </a:rPr>
-              <a:t>Same repository, same model, same three tasks. Only the way we prompt them differs.</a:t>
+              <a:t>Same repository, same model, same four tasks. Only the way we prompt them differs.</a:t>
             </a:r>
             <a:endParaRPr lang="en-US" sz="1500" dirty="0"/>
           </a:p>
@@ -14004,7 +14004,7 @@
                   <a:schemeClr val="accent3"/>
                 </a:solidFill>
               </a:rPr>
-              <a:t>One conversation · three one-line prompts · no files, no constraints, no test command</a:t>
+              <a:t>One conversation · four one-line prompts · no files, no constraints, no test command</a:t>
             </a:r>
             <a:endParaRPr lang="en-US" sz="1400" dirty="0"/>
           </a:p>
@@ -14018,8 +14018,8 @@
         </p:nvSpPr>
         <p:spPr>
           <a:xfrm>
-            <a:off x="5760720" y="2148840"/>
-            <a:ext cx="1737360" cy="548640"/>
+            <a:off x="5669280" y="2148840"/>
+            <a:ext cx="1325880" cy="548640"/>
           </a:xfrm>
           <a:prstGeom prst="roundRect">
             <a:avLst>
@@ -14045,8 +14045,8 @@
         </p:nvSpPr>
         <p:spPr>
           <a:xfrm>
-            <a:off x="5760720" y="2148840"/>
-            <a:ext cx="1737360" cy="548640"/>
+            <a:off x="5669280" y="2148840"/>
+            <a:ext cx="1325880" cy="548640"/>
           </a:xfrm>
           <a:prstGeom prst="rect">
             <a:avLst/>
@@ -14062,14 +14062,14 @@
               <a:buNone/>
             </a:pPr>
             <a:r>
-              <a:rPr lang="en-US" sz="1400" b="1" dirty="0">
+              <a:rPr lang="en-US" sz="1300" b="1" dirty="0">
                 <a:solidFill>
                   <a:schemeClr val="tx1"/>
                 </a:solidFill>
               </a:rPr>
-              <a:t>1  Tax bug</a:t>
-            </a:r>
-            <a:endParaRPr lang="en-US" sz="1400" dirty="0"/>
+              <a:t>Tax bug</a:t>
+            </a:r>
+            <a:endParaRPr lang="en-US" sz="1300" dirty="0"/>
           </a:p>
         </p:txBody>
       </p:sp>
@@ -14081,8 +14081,8 @@
         </p:nvSpPr>
         <p:spPr>
           <a:xfrm>
-            <a:off x="7680960" y="2148840"/>
-            <a:ext cx="1737360" cy="548640"/>
+            <a:off x="7132320" y="2148840"/>
+            <a:ext cx="1325880" cy="548640"/>
           </a:xfrm>
           <a:prstGeom prst="roundRect">
             <a:avLst>
@@ -14108,8 +14108,8 @@
         </p:nvSpPr>
         <p:spPr>
           <a:xfrm>
-            <a:off x="7680960" y="2148840"/>
-            <a:ext cx="1737360" cy="548640"/>
+            <a:off x="7132320" y="2148840"/>
+            <a:ext cx="1325880" cy="548640"/>
           </a:xfrm>
           <a:prstGeom prst="rect">
             <a:avLst/>
@@ -14125,14 +14125,14 @@
               <a:buNone/>
             </a:pPr>
             <a:r>
-              <a:rPr lang="en-US" sz="1400" b="1" dirty="0">
+              <a:rPr lang="en-US" sz="1300" b="1" dirty="0">
                 <a:solidFill>
                   <a:schemeClr val="tx1"/>
                 </a:solidFill>
               </a:rPr>
-              <a:t>3  Free shipping</a:t>
-            </a:r>
-            <a:endParaRPr lang="en-US" sz="1400" dirty="0"/>
+              <a:t>Free shipping</a:t>
+            </a:r>
+            <a:endParaRPr lang="en-US" sz="1300" dirty="0"/>
           </a:p>
         </p:txBody>
       </p:sp>
@@ -14144,8 +14144,8 @@
         </p:nvSpPr>
         <p:spPr>
           <a:xfrm>
-            <a:off x="9601200" y="2148840"/>
-            <a:ext cx="1737360" cy="548640"/>
+            <a:off x="8595360" y="2148840"/>
+            <a:ext cx="1325880" cy="548640"/>
           </a:xfrm>
           <a:prstGeom prst="roundRect">
             <a:avLst>
@@ -14171,8 +14171,8 @@
         </p:nvSpPr>
         <p:spPr>
           <a:xfrm>
-            <a:off x="9601200" y="2148840"/>
-            <a:ext cx="1737360" cy="548640"/>
+            <a:off x="8595360" y="2148840"/>
+            <a:ext cx="1325880" cy="548640"/>
           </a:xfrm>
           <a:prstGeom prst="rect">
             <a:avLst/>
@@ -14188,20 +14188,83 @@
               <a:buNone/>
             </a:pPr>
             <a:r>
-              <a:rPr lang="en-US" sz="1400" b="1" dirty="0">
+              <a:rPr lang="en-US" sz="1300" b="1" dirty="0">
                 <a:solidFill>
                   <a:schemeClr val="tx1"/>
                 </a:solidFill>
               </a:rPr>
-              <a:t>4  Retry limit</a:t>
-            </a:r>
-            <a:endParaRPr lang="en-US" sz="1400" dirty="0"/>
-          </a:p>
-        </p:txBody>
-      </p:sp>
-      <p:sp>
-        <p:nvSpPr>
-          <p:cNvPr id="16" name="panel"/>
+              <a:t>Discount cap</a:t>
+            </a:r>
+            <a:endParaRPr lang="en-US" sz="1300" dirty="0"/>
+          </a:p>
+        </p:txBody>
+      </p:sp>
+      <p:sp>
+        <p:nvSpPr>
+          <p:cNvPr id="16" name="task chip"/>
+          <p:cNvSpPr/>
+          <p:nvPr/>
+        </p:nvSpPr>
+        <p:spPr>
+          <a:xfrm>
+            <a:off x="10058400" y="2148840"/>
+            <a:ext cx="1325880" cy="548640"/>
+          </a:xfrm>
+          <a:prstGeom prst="roundRect">
+            <a:avLst>
+              <a:gd name="adj" fmla="val 13333"/>
+            </a:avLst>
+          </a:prstGeom>
+          <a:solidFill>
+            <a:schemeClr val="bg1"/>
+          </a:solidFill>
+          <a:ln w="15875">
+            <a:solidFill>
+              <a:schemeClr val="accent3"/>
+            </a:solidFill>
+            <a:prstDash val="solid"/>
+          </a:ln>
+        </p:spPr>
+      </p:sp>
+      <p:sp>
+        <p:nvSpPr>
+          <p:cNvPr id="17" name="Text 15"/>
+          <p:cNvSpPr txBox="1"/>
+          <p:nvPr/>
+        </p:nvSpPr>
+        <p:spPr>
+          <a:xfrm>
+            <a:off x="10058400" y="2148840"/>
+            <a:ext cx="1325880" cy="548640"/>
+          </a:xfrm>
+          <a:prstGeom prst="rect">
+            <a:avLst/>
+          </a:prstGeom>
+          <a:noFill/>
+          <a:ln/>
+        </p:spPr>
+        <p:txBody>
+          <a:bodyPr wrap="square" lIns="0" tIns="0" rIns="0" bIns="0" rtlCol="0" anchor="ctr"/>
+          <a:lstStyle/>
+          <a:p>
+            <a:pPr algn="ctr" indent="0" marL="0">
+              <a:buNone/>
+            </a:pPr>
+            <a:r>
+              <a:rPr lang="en-US" sz="1300" b="1" dirty="0">
+                <a:solidFill>
+                  <a:schemeClr val="tx1"/>
+                </a:solidFill>
+              </a:rPr>
+              <a:t>Retry limit</a:t>
+            </a:r>
+            <a:endParaRPr lang="en-US" sz="1300" dirty="0"/>
+          </a:p>
+        </p:txBody>
+      </p:sp>
+      <p:sp>
+        <p:nvSpPr>
+          <p:cNvPr id="18" name="panel"/>
           <p:cNvSpPr/>
           <p:nvPr/>
         </p:nvSpPr>
@@ -14228,7 +14291,7 @@
       </p:sp>
       <p:sp>
         <p:nvSpPr>
-          <p:cNvPr id="17" name="glyph circle"/>
+          <p:cNvPr id="19" name="glyph circle"/>
           <p:cNvSpPr/>
           <p:nvPr/>
         </p:nvSpPr>
@@ -14253,7 +14316,7 @@
       </p:sp>
       <p:sp>
         <p:nvSpPr>
-          <p:cNvPr id="18" name="Text 16"/>
+          <p:cNvPr id="20" name="Text 18"/>
           <p:cNvSpPr txBox="1"/>
           <p:nvPr/>
         </p:nvSpPr>
@@ -14289,7 +14352,7 @@
       </p:sp>
       <p:sp>
         <p:nvSpPr>
-          <p:cNvPr id="19" name="Text 17"/>
+          <p:cNvPr id="21" name="Text 19"/>
           <p:cNvSpPr txBox="1"/>
           <p:nvPr/>
         </p:nvSpPr>
@@ -14325,7 +14388,7 @@
       </p:sp>
       <p:sp>
         <p:nvSpPr>
-          <p:cNvPr id="20" name="Text 18"/>
+          <p:cNvPr id="22" name="Text 20"/>
           <p:cNvSpPr txBox="1"/>
           <p:nvPr/>
         </p:nvSpPr>
@@ -14361,14 +14424,14 @@
       </p:sp>
       <p:sp>
         <p:nvSpPr>
-          <p:cNvPr id="21" name="task chip"/>
+          <p:cNvPr id="23" name="task chip"/>
           <p:cNvSpPr/>
           <p:nvPr/>
         </p:nvSpPr>
         <p:spPr>
           <a:xfrm>
-            <a:off x="5760720" y="3749040"/>
-            <a:ext cx="1737360" cy="548640"/>
+            <a:off x="5669280" y="3749040"/>
+            <a:ext cx="1325880" cy="548640"/>
           </a:xfrm>
           <a:prstGeom prst="roundRect">
             <a:avLst>
@@ -14388,14 +14451,14 @@
       </p:sp>
       <p:sp>
         <p:nvSpPr>
-          <p:cNvPr id="22" name="Text 20"/>
+          <p:cNvPr id="24" name="Text 22"/>
           <p:cNvSpPr txBox="1"/>
           <p:nvPr/>
         </p:nvSpPr>
         <p:spPr>
           <a:xfrm>
-            <a:off x="5760720" y="3749040"/>
-            <a:ext cx="1737360" cy="548640"/>
+            <a:off x="5669280" y="3749040"/>
+            <a:ext cx="1325880" cy="548640"/>
           </a:xfrm>
           <a:prstGeom prst="rect">
             <a:avLst/>
@@ -14411,27 +14474,27 @@
               <a:buNone/>
             </a:pPr>
             <a:r>
-              <a:rPr lang="en-US" sz="1400" b="1" dirty="0">
+              <a:rPr lang="en-US" sz="1300" b="1" dirty="0">
                 <a:solidFill>
                   <a:schemeClr val="tx1"/>
                 </a:solidFill>
               </a:rPr>
-              <a:t>1  Tax bug</a:t>
-            </a:r>
-            <a:endParaRPr lang="en-US" sz="1400" dirty="0"/>
-          </a:p>
-        </p:txBody>
-      </p:sp>
-      <p:sp>
-        <p:nvSpPr>
-          <p:cNvPr id="23" name="task chip"/>
+              <a:t>Tax bug</a:t>
+            </a:r>
+            <a:endParaRPr lang="en-US" sz="1300" dirty="0"/>
+          </a:p>
+        </p:txBody>
+      </p:sp>
+      <p:sp>
+        <p:nvSpPr>
+          <p:cNvPr id="25" name="task chip"/>
           <p:cNvSpPr/>
           <p:nvPr/>
         </p:nvSpPr>
         <p:spPr>
           <a:xfrm>
-            <a:off x="7680960" y="3749040"/>
-            <a:ext cx="1737360" cy="548640"/>
+            <a:off x="7132320" y="3749040"/>
+            <a:ext cx="1325880" cy="548640"/>
           </a:xfrm>
           <a:prstGeom prst="roundRect">
             <a:avLst>
@@ -14451,14 +14514,14 @@
       </p:sp>
       <p:sp>
         <p:nvSpPr>
-          <p:cNvPr id="24" name="Text 22"/>
+          <p:cNvPr id="26" name="Text 24"/>
           <p:cNvSpPr txBox="1"/>
           <p:nvPr/>
         </p:nvSpPr>
         <p:spPr>
           <a:xfrm>
-            <a:off x="7680960" y="3749040"/>
-            <a:ext cx="1737360" cy="548640"/>
+            <a:off x="7132320" y="3749040"/>
+            <a:ext cx="1325880" cy="548640"/>
           </a:xfrm>
           <a:prstGeom prst="rect">
             <a:avLst/>
@@ -14474,27 +14537,27 @@
               <a:buNone/>
             </a:pPr>
             <a:r>
-              <a:rPr lang="en-US" sz="1400" b="1" dirty="0">
+              <a:rPr lang="en-US" sz="1300" b="1" dirty="0">
                 <a:solidFill>
                   <a:schemeClr val="tx1"/>
                 </a:solidFill>
               </a:rPr>
-              <a:t>3  Free shipping</a:t>
-            </a:r>
-            <a:endParaRPr lang="en-US" sz="1400" dirty="0"/>
-          </a:p>
-        </p:txBody>
-      </p:sp>
-      <p:sp>
-        <p:nvSpPr>
-          <p:cNvPr id="25" name="task chip"/>
+              <a:t>Free shipping</a:t>
+            </a:r>
+            <a:endParaRPr lang="en-US" sz="1300" dirty="0"/>
+          </a:p>
+        </p:txBody>
+      </p:sp>
+      <p:sp>
+        <p:nvSpPr>
+          <p:cNvPr id="27" name="task chip"/>
           <p:cNvSpPr/>
           <p:nvPr/>
         </p:nvSpPr>
         <p:spPr>
           <a:xfrm>
-            <a:off x="9601200" y="3749040"/>
-            <a:ext cx="1737360" cy="548640"/>
+            <a:off x="8595360" y="3749040"/>
+            <a:ext cx="1325880" cy="548640"/>
           </a:xfrm>
           <a:prstGeom prst="roundRect">
             <a:avLst>
@@ -14514,14 +14577,14 @@
       </p:sp>
       <p:sp>
         <p:nvSpPr>
-          <p:cNvPr id="26" name="Text 24"/>
+          <p:cNvPr id="28" name="Text 26"/>
           <p:cNvSpPr txBox="1"/>
           <p:nvPr/>
         </p:nvSpPr>
         <p:spPr>
           <a:xfrm>
-            <a:off x="9601200" y="3749040"/>
-            <a:ext cx="1737360" cy="548640"/>
+            <a:off x="8595360" y="3749040"/>
+            <a:ext cx="1325880" cy="548640"/>
           </a:xfrm>
           <a:prstGeom prst="rect">
             <a:avLst/>
@@ -14537,20 +14600,83 @@
               <a:buNone/>
             </a:pPr>
             <a:r>
-              <a:rPr lang="en-US" sz="1400" b="1" dirty="0">
+              <a:rPr lang="en-US" sz="1300" b="1" dirty="0">
                 <a:solidFill>
                   <a:schemeClr val="tx1"/>
                 </a:solidFill>
               </a:rPr>
-              <a:t>4  Retry limit</a:t>
-            </a:r>
-            <a:endParaRPr lang="en-US" sz="1400" dirty="0"/>
-          </a:p>
-        </p:txBody>
-      </p:sp>
-      <p:sp>
-        <p:nvSpPr>
-          <p:cNvPr id="27" name="panel"/>
+              <a:t>Discount cap</a:t>
+            </a:r>
+            <a:endParaRPr lang="en-US" sz="1300" dirty="0"/>
+          </a:p>
+        </p:txBody>
+      </p:sp>
+      <p:sp>
+        <p:nvSpPr>
+          <p:cNvPr id="29" name="task chip"/>
+          <p:cNvSpPr/>
+          <p:nvPr/>
+        </p:nvSpPr>
+        <p:spPr>
+          <a:xfrm>
+            <a:off x="10058400" y="3749040"/>
+            <a:ext cx="1325880" cy="548640"/>
+          </a:xfrm>
+          <a:prstGeom prst="roundRect">
+            <a:avLst>
+              <a:gd name="adj" fmla="val 13333"/>
+            </a:avLst>
+          </a:prstGeom>
+          <a:solidFill>
+            <a:schemeClr val="bg1"/>
+          </a:solidFill>
+          <a:ln w="15875">
+            <a:solidFill>
+              <a:schemeClr val="accent2"/>
+            </a:solidFill>
+            <a:prstDash val="solid"/>
+          </a:ln>
+        </p:spPr>
+      </p:sp>
+      <p:sp>
+        <p:nvSpPr>
+          <p:cNvPr id="30" name="Text 28"/>
+          <p:cNvSpPr txBox="1"/>
+          <p:nvPr/>
+        </p:nvSpPr>
+        <p:spPr>
+          <a:xfrm>
+            <a:off x="10058400" y="3749040"/>
+            <a:ext cx="1325880" cy="548640"/>
+          </a:xfrm>
+          <a:prstGeom prst="rect">
+            <a:avLst/>
+          </a:prstGeom>
+          <a:noFill/>
+          <a:ln/>
+        </p:spPr>
+        <p:txBody>
+          <a:bodyPr wrap="square" lIns="0" tIns="0" rIns="0" bIns="0" rtlCol="0" anchor="ctr"/>
+          <a:lstStyle/>
+          <a:p>
+            <a:pPr algn="ctr" indent="0" marL="0">
+              <a:buNone/>
+            </a:pPr>
+            <a:r>
+              <a:rPr lang="en-US" sz="1300" b="1" dirty="0">
+                <a:solidFill>
+                  <a:schemeClr val="tx1"/>
+                </a:solidFill>
+              </a:rPr>
+              <a:t>Retry limit</a:t>
+            </a:r>
+            <a:endParaRPr lang="en-US" sz="1300" dirty="0"/>
+          </a:p>
+        </p:txBody>
+      </p:sp>
+      <p:sp>
+        <p:nvSpPr>
+          <p:cNvPr id="31" name="panel"/>
           <p:cNvSpPr/>
           <p:nvPr/>
         </p:nvSpPr>
@@ -14577,7 +14703,7 @@
       </p:sp>
       <p:sp>
         <p:nvSpPr>
-          <p:cNvPr id="28" name="Text 26"/>
+          <p:cNvPr id="32" name="Text 30"/>
           <p:cNvSpPr txBox="1"/>
           <p:nvPr/>
         </p:nvSpPr>
@@ -14605,7 +14731,7 @@
                   <a:schemeClr val="tx2"/>
                 </a:solidFill>
               </a:rPr>
-              <a:t>We will not look at it again until minute 54. Then we read the scoreboard together.</a:t>
+              <a:t>Then a QA round: any failed check goes back to that lane once, like a real QA ticket. We read the scoreboard at minute 54.</a:t>
             </a:r>
             <a:endParaRPr lang="en-US" sz="1500" dirty="0"/>
           </a:p>
@@ -17580,7 +17706,7 @@
                   <a:schemeClr val="accent3"/>
                 </a:solidFill>
               </a:rPr>
-              <a:t>Same model, same repo, same three tasks. Live numbers from the race terminal; rehearsal numbers below.</a:t>
+              <a:t>Same model, same repo, same four tasks, then one QA round. Live numbers from the race terminal; rehearsal numbers below.</a:t>
             </a:r>
             <a:endParaRPr lang="en-US" sz="1500" dirty="0"/>
           </a:p>
@@ -17613,7 +17739,7 @@
                 <a:gridCol w="1828800"/>
                 <a:gridCol w="1828800"/>
               </a:tblGrid>
-              <a:tr h="457200">
+              <a:tr h="420624">
                 <a:tc>
                   <a:txBody>
                     <a:bodyPr/>
@@ -17798,7 +17924,7 @@
                   </a:tcPr>
                 </a:tc>
               </a:tr>
-              <a:tr h="457200">
+              <a:tr h="420624">
                 <a:tc>
                   <a:txBody>
                     <a:bodyPr/>
@@ -17813,7 +17939,7 @@
                             <a:schemeClr val="tx1"/>
                           </a:solidFill>
                         </a:rPr>
-                        <a:t>Hidden verification passed</a:t>
+                        <a:t>Hidden verification passed, first try</a:t>
                       </a:r>
                       <a:endParaRPr lang="en-US" sz="1400" dirty="0"/>
                     </a:p>
@@ -17871,7 +17997,7 @@
                             <a:schemeClr val="tx1"/>
                           </a:solidFill>
                         </a:rPr>
-                        <a:t>2 / 3</a:t>
+                        <a:t>3 / 4</a:t>
                       </a:r>
                       <a:endParaRPr lang="en-US" sz="1400" dirty="0"/>
                     </a:p>
@@ -17929,7 +18055,7 @@
                             <a:schemeClr val="tx1"/>
                           </a:solidFill>
                         </a:rPr>
-                        <a:t>3 / 3</a:t>
+                        <a:t>4 / 4</a:t>
                       </a:r>
                       <a:endParaRPr lang="en-US" sz="1400" dirty="0"/>
                     </a:p>
@@ -17974,7 +18100,183 @@
                   </a:tcPr>
                 </a:tc>
               </a:tr>
-              <a:tr h="457200">
+              <a:tr h="420624">
+                <a:tc>
+                  <a:txBody>
+                    <a:bodyPr/>
+                    <a:lstStyle/>
+                    <a:p>
+                      <a:pPr indent="0" marL="0">
+                        <a:buNone/>
+                      </a:pPr>
+                      <a:r>
+                        <a:rPr lang="en-US" sz="1400" b="1" dirty="0">
+                          <a:solidFill>
+                            <a:schemeClr val="tx1"/>
+                          </a:solidFill>
+                        </a:rPr>
+                        <a:t>...after one QA round</a:t>
+                      </a:r>
+                      <a:endParaRPr lang="en-US" sz="1400" dirty="0"/>
+                    </a:p>
+                  </a:txBody>
+                  <a:tcPr marL="128016" marR="128016" marT="36576" marB="36576" anchor="ctr">
+                    <a:lnL w="12700" cap="flat" cmpd="sng" algn="ctr">
+                      <a:solidFill>
+                        <a:srgbClr val="EAF0F4"/>
+                      </a:solidFill>
+                      <a:prstDash val="solid"/>
+                      <a:round/>
+                      <a:headEnd type="none" w="med" len="med"/>
+                      <a:tailEnd type="none" w="med" len="med"/>
+                    </a:lnL>
+                    <a:lnR w="12700" cap="flat" cmpd="sng" algn="ctr">
+                      <a:solidFill>
+                        <a:srgbClr val="EAF0F4"/>
+                      </a:solidFill>
+                      <a:prstDash val="solid"/>
+                      <a:round/>
+                      <a:headEnd type="none" w="med" len="med"/>
+                      <a:tailEnd type="none" w="med" len="med"/>
+                    </a:lnR>
+                    <a:lnT w="12700" cap="flat" cmpd="sng" algn="ctr">
+                      <a:solidFill>
+                        <a:srgbClr val="EAF0F4"/>
+                      </a:solidFill>
+                      <a:prstDash val="solid"/>
+                      <a:round/>
+                      <a:headEnd type="none" w="med" len="med"/>
+                      <a:tailEnd type="none" w="med" len="med"/>
+                    </a:lnT>
+                    <a:lnB w="12700" cap="flat" cmpd="sng" algn="ctr">
+                      <a:solidFill>
+                        <a:srgbClr val="EAF0F4"/>
+                      </a:solidFill>
+                      <a:prstDash val="solid"/>
+                      <a:round/>
+                      <a:headEnd type="none" w="med" len="med"/>
+                      <a:tailEnd type="none" w="med" len="med"/>
+                    </a:lnB>
+                  </a:tcPr>
+                </a:tc>
+                <a:tc>
+                  <a:txBody>
+                    <a:bodyPr/>
+                    <a:lstStyle/>
+                    <a:p>
+                      <a:pPr algn="ctr" indent="0" marL="0">
+                        <a:buNone/>
+                      </a:pPr>
+                      <a:r>
+                        <a:rPr lang="en-US" sz="1400" dirty="0">
+                          <a:solidFill>
+                            <a:schemeClr val="tx1"/>
+                          </a:solidFill>
+                        </a:rPr>
+                        <a:t>4 / 4</a:t>
+                      </a:r>
+                      <a:endParaRPr lang="en-US" sz="1400" dirty="0"/>
+                    </a:p>
+                  </a:txBody>
+                  <a:tcPr marL="128016" marR="128016" marT="36576" marB="36576" anchor="ctr">
+                    <a:lnL w="12700" cap="flat" cmpd="sng" algn="ctr">
+                      <a:solidFill>
+                        <a:srgbClr val="EAF0F4"/>
+                      </a:solidFill>
+                      <a:prstDash val="solid"/>
+                      <a:round/>
+                      <a:headEnd type="none" w="med" len="med"/>
+                      <a:tailEnd type="none" w="med" len="med"/>
+                    </a:lnL>
+                    <a:lnR w="12700" cap="flat" cmpd="sng" algn="ctr">
+                      <a:solidFill>
+                        <a:srgbClr val="EAF0F4"/>
+                      </a:solidFill>
+                      <a:prstDash val="solid"/>
+                      <a:round/>
+                      <a:headEnd type="none" w="med" len="med"/>
+                      <a:tailEnd type="none" w="med" len="med"/>
+                    </a:lnR>
+                    <a:lnT w="12700" cap="flat" cmpd="sng" algn="ctr">
+                      <a:solidFill>
+                        <a:srgbClr val="EAF0F4"/>
+                      </a:solidFill>
+                      <a:prstDash val="solid"/>
+                      <a:round/>
+                      <a:headEnd type="none" w="med" len="med"/>
+                      <a:tailEnd type="none" w="med" len="med"/>
+                    </a:lnT>
+                    <a:lnB w="12700" cap="flat" cmpd="sng" algn="ctr">
+                      <a:solidFill>
+                        <a:srgbClr val="EAF0F4"/>
+                      </a:solidFill>
+                      <a:prstDash val="solid"/>
+                      <a:round/>
+                      <a:headEnd type="none" w="med" len="med"/>
+                      <a:tailEnd type="none" w="med" len="med"/>
+                    </a:lnB>
+                  </a:tcPr>
+                </a:tc>
+                <a:tc>
+                  <a:txBody>
+                    <a:bodyPr/>
+                    <a:lstStyle/>
+                    <a:p>
+                      <a:pPr algn="ctr" indent="0" marL="0">
+                        <a:buNone/>
+                      </a:pPr>
+                      <a:r>
+                        <a:rPr lang="en-US" sz="1400" dirty="0">
+                          <a:solidFill>
+                            <a:schemeClr val="tx1"/>
+                          </a:solidFill>
+                        </a:rPr>
+                        <a:t>4 / 4</a:t>
+                      </a:r>
+                      <a:endParaRPr lang="en-US" sz="1400" dirty="0"/>
+                    </a:p>
+                  </a:txBody>
+                  <a:tcPr marL="128016" marR="128016" marT="36576" marB="36576" anchor="ctr">
+                    <a:lnL w="12700" cap="flat" cmpd="sng" algn="ctr">
+                      <a:solidFill>
+                        <a:srgbClr val="EAF0F4"/>
+                      </a:solidFill>
+                      <a:prstDash val="solid"/>
+                      <a:round/>
+                      <a:headEnd type="none" w="med" len="med"/>
+                      <a:tailEnd type="none" w="med" len="med"/>
+                    </a:lnL>
+                    <a:lnR w="12700" cap="flat" cmpd="sng" algn="ctr">
+                      <a:solidFill>
+                        <a:srgbClr val="EAF0F4"/>
+                      </a:solidFill>
+                      <a:prstDash val="solid"/>
+                      <a:round/>
+                      <a:headEnd type="none" w="med" len="med"/>
+                      <a:tailEnd type="none" w="med" len="med"/>
+                    </a:lnR>
+                    <a:lnT w="12700" cap="flat" cmpd="sng" algn="ctr">
+                      <a:solidFill>
+                        <a:srgbClr val="EAF0F4"/>
+                      </a:solidFill>
+                      <a:prstDash val="solid"/>
+                      <a:round/>
+                      <a:headEnd type="none" w="med" len="med"/>
+                      <a:tailEnd type="none" w="med" len="med"/>
+                    </a:lnT>
+                    <a:lnB w="12700" cap="flat" cmpd="sng" algn="ctr">
+                      <a:solidFill>
+                        <a:srgbClr val="EAF0F4"/>
+                      </a:solidFill>
+                      <a:prstDash val="solid"/>
+                      <a:round/>
+                      <a:headEnd type="none" w="med" len="med"/>
+                      <a:tailEnd type="none" w="med" len="med"/>
+                    </a:lnB>
+                  </a:tcPr>
+                </a:tc>
+              </a:tr>
+              <a:tr h="420624">
                 <a:tc>
                   <a:txBody>
                     <a:bodyPr/>
@@ -18047,7 +18349,7 @@
                             <a:schemeClr val="tx1"/>
                           </a:solidFill>
                         </a:rPr>
-                        <a:t>7 / 7</a:t>
+                        <a:t>9 / 9</a:t>
                       </a:r>
                       <a:endParaRPr lang="en-US" sz="1400" dirty="0"/>
                     </a:p>
@@ -18105,7 +18407,7 @@
                             <a:schemeClr val="tx1"/>
                           </a:solidFill>
                         </a:rPr>
-                        <a:t>9 / 8</a:t>
+                        <a:t>11 / 10</a:t>
                       </a:r>
                       <a:endParaRPr lang="en-US" sz="1400" dirty="0"/>
                     </a:p>
@@ -18150,7 +18452,7 @@
                   </a:tcPr>
                 </a:tc>
               </a:tr>
-              <a:tr h="457200">
+              <a:tr h="420624">
                 <a:tc>
                   <a:txBody>
                     <a:bodyPr/>
@@ -18223,7 +18525,7 @@
                             <a:schemeClr val="tx1"/>
                           </a:solidFill>
                         </a:rPr>
-                        <a:t>3 (0)</a:t>
+                        <a:t>5 (1)</a:t>
                       </a:r>
                       <a:endParaRPr lang="en-US" sz="1400" dirty="0"/>
                     </a:p>
@@ -18281,7 +18583,7 @@
                             <a:schemeClr val="tx1"/>
                           </a:solidFill>
                         </a:rPr>
-                        <a:t>3 (0)</a:t>
+                        <a:t>4 (0)</a:t>
                       </a:r>
                       <a:endParaRPr lang="en-US" sz="1400" dirty="0"/>
                     </a:p>
@@ -18326,7 +18628,7 @@
                   </a:tcPr>
                 </a:tc>
               </a:tr>
-              <a:tr h="457200">
+              <a:tr h="420624">
                 <a:tc>
                   <a:txBody>
                     <a:bodyPr/>
@@ -18399,7 +18701,7 @@
                             <a:schemeClr val="tx1"/>
                           </a:solidFill>
                         </a:rPr>
-                        <a:t>5 / 0</a:t>
+                        <a:t>5 / 1</a:t>
                       </a:r>
                       <a:endParaRPr lang="en-US" sz="1400" dirty="0"/>
                     </a:p>
@@ -18457,7 +18759,7 @@
                             <a:schemeClr val="tx1"/>
                           </a:solidFill>
                         </a:rPr>
-                        <a:t>0 / 3</a:t>
+                        <a:t>0 / 4</a:t>
                       </a:r>
                       <a:endParaRPr lang="en-US" sz="1400" dirty="0"/>
                     </a:p>
@@ -18502,7 +18804,7 @@
                   </a:tcPr>
                 </a:tc>
               </a:tr>
-              <a:tr h="457200">
+              <a:tr h="420624">
                 <a:tc>
                   <a:txBody>
                     <a:bodyPr/>
@@ -18575,7 +18877,7 @@
                             <a:schemeClr val="tx1"/>
                           </a:solidFill>
                         </a:rPr>
-                        <a:t>1</a:t>
+                        <a:t>0</a:t>
                       </a:r>
                       <a:endParaRPr lang="en-US" sz="1400" dirty="0"/>
                     </a:p>
@@ -18633,7 +18935,7 @@
                             <a:schemeClr val="tx1"/>
                           </a:solidFill>
                         </a:rPr>
-                        <a:t>1</a:t>
+                        <a:t>0</a:t>
                       </a:r>
                       <a:endParaRPr lang="en-US" sz="1400" dirty="0"/>
                     </a:p>
@@ -18678,7 +18980,7 @@
                   </a:tcPr>
                 </a:tc>
               </a:tr>
-              <a:tr h="457200">
+              <a:tr h="420624">
                 <a:tc>
                   <a:txBody>
                     <a:bodyPr/>
@@ -18751,7 +19053,7 @@
                             <a:schemeClr val="tx1"/>
                           </a:solidFill>
                         </a:rPr>
-                        <a:t>60.0k</a:t>
+                        <a:t>68.7k</a:t>
                       </a:r>
                       <a:endParaRPr lang="en-US" sz="1400" dirty="0"/>
                     </a:p>
@@ -18809,7 +19111,7 @@
                             <a:schemeClr val="tx1"/>
                           </a:solidFill>
                         </a:rPr>
-                        <a:t>51.3k</a:t>
+                        <a:t>49.2k</a:t>
                       </a:r>
                       <a:endParaRPr lang="en-US" sz="1400" dirty="0"/>
                     </a:p>
@@ -18854,7 +19156,7 @@
                   </a:tcPr>
                 </a:tc>
               </a:tr>
-              <a:tr h="457200">
+              <a:tr h="420624">
                 <a:tc>
                   <a:txBody>
                     <a:bodyPr/>
@@ -18869,7 +19171,7 @@
                             <a:schemeClr val="tx1"/>
                           </a:solidFill>
                         </a:rPr>
-                        <a:t>Cost · tokens processed</a:t>
+                        <a:t>Cost, incl. rework</a:t>
                       </a:r>
                       <a:endParaRPr lang="en-US" sz="1400" dirty="0"/>
                     </a:p>
@@ -18927,7 +19229,7 @@
                             <a:schemeClr val="tx1"/>
                           </a:solidFill>
                         </a:rPr>
-                        <a:t>$0.90 · 907k</a:t>
+                        <a:t>$1.50</a:t>
                       </a:r>
                       <a:endParaRPr lang="en-US" sz="1400" dirty="0"/>
                     </a:p>
@@ -18985,7 +19287,7 @@
                             <a:schemeClr val="tx1"/>
                           </a:solidFill>
                         </a:rPr>
-                        <a:t>$0.60 · 729k</a:t>
+                        <a:t>$0.72</a:t>
                       </a:r>
                       <a:endParaRPr lang="en-US" sz="1400" dirty="0"/>
                     </a:p>
@@ -19030,7 +19332,7 @@
                   </a:tcPr>
                 </a:tc>
               </a:tr>
-              <a:tr h="457200">
+              <a:tr h="420624">
                 <a:tc>
                   <a:txBody>
                     <a:bodyPr/>
@@ -19103,7 +19405,7 @@
                             <a:schemeClr val="tx1"/>
                           </a:solidFill>
                         </a:rPr>
-                        <a:t>2.2</a:t>
+                        <a:t>3.0</a:t>
                       </a:r>
                       <a:endParaRPr lang="en-US" sz="1400" dirty="0"/>
                     </a:p>
@@ -19161,7 +19463,7 @@
                             <a:schemeClr val="tx1"/>
                           </a:solidFill>
                         </a:rPr>
-                        <a:t>1.7</a:t>
+                        <a:t>2.1</a:t>
                       </a:r>
                       <a:endParaRPr lang="en-US" sz="1400" dirty="0"/>
                     </a:p>
@@ -19212,7 +19514,43 @@
       </p:graphicFrame>
       <p:sp>
         <p:nvSpPr>
-          <p:cNvPr id="6" name="panel"/>
+          <p:cNvPr id="6" name="Text 3"/>
+          <p:cNvSpPr txBox="1"/>
+          <p:nvPr/>
+        </p:nvSpPr>
+        <p:spPr>
+          <a:xfrm>
+            <a:off x="640080" y="5943600"/>
+            <a:ext cx="7498080" cy="274320"/>
+          </a:xfrm>
+          <a:prstGeom prst="rect">
+            <a:avLst/>
+          </a:prstGeom>
+          <a:noFill/>
+          <a:ln/>
+        </p:spPr>
+        <p:txBody>
+          <a:bodyPr wrap="square" lIns="0" tIns="0" rIns="0" bIns="0" rtlCol="0" anchor="t"/>
+          <a:lstStyle/>
+          <a:p>
+            <a:pPr indent="0" marL="0">
+              <a:buNone/>
+            </a:pPr>
+            <a:r>
+              <a:rPr lang="en-US" sz="1200" i="1" dirty="0">
+                <a:solidFill>
+                  <a:schemeClr val="accent6"/>
+                </a:solidFill>
+              </a:rPr>
+              <a:t>Files read is even: good docs kept both lanes on the right files (Theory 3).</a:t>
+            </a:r>
+            <a:endParaRPr lang="en-US" sz="1200" dirty="0"/>
+          </a:p>
+        </p:txBody>
+      </p:sp>
+      <p:sp>
+        <p:nvSpPr>
+          <p:cNvPr id="7" name="panel"/>
           <p:cNvSpPr/>
           <p:nvPr/>
         </p:nvSpPr>
@@ -19239,7 +19577,7 @@
       </p:sp>
       <p:sp>
         <p:nvSpPr>
-          <p:cNvPr id="7" name="glyph circle"/>
+          <p:cNvPr id="8" name="glyph circle"/>
           <p:cNvSpPr/>
           <p:nvPr/>
         </p:nvSpPr>
@@ -19264,7 +19602,7 @@
       </p:sp>
       <p:sp>
         <p:nvSpPr>
-          <p:cNvPr id="8" name="Text 5"/>
+          <p:cNvPr id="9" name="Text 6"/>
           <p:cNvSpPr txBox="1"/>
           <p:nvPr/>
         </p:nvSpPr>
@@ -19300,7 +19638,7 @@
       </p:sp>
       <p:sp>
         <p:nvSpPr>
-          <p:cNvPr id="9" name="Text 6"/>
+          <p:cNvPr id="10" name="Text 7"/>
           <p:cNvSpPr txBox="1"/>
           <p:nvPr/>
         </p:nvSpPr>
@@ -19336,7 +19674,7 @@
       </p:sp>
       <p:sp>
         <p:nvSpPr>
-          <p:cNvPr id="10" name="Text 7"/>
+          <p:cNvPr id="11" name="Text 8"/>
           <p:cNvSpPr txBox="1"/>
           <p:nvPr/>
         </p:nvSpPr>
@@ -19372,7 +19710,7 @@
       </p:sp>
       <p:sp>
         <p:nvSpPr>
-          <p:cNvPr id="11" name="Text 8"/>
+          <p:cNvPr id="12" name="Text 9"/>
           <p:cNvSpPr txBox="1"/>
           <p:nvPr/>
         </p:nvSpPr>

</xml_diff>